<commit_message>
Hyda Slides: tables, charts, shapes, rotation, animations, presenter view, PDF
- Sixteen preset shapes, lines and arrows, gradient fills (shapes and
  backgrounds), rotation and flips with a rotate handle
- Tables with cell editing, Tab navigation, row/column insert and delete,
  header and banded rows
- Charts (column, bar, line, area, pie) with a data editor
- Entrance animations (appear, fade, fly in) with click-by-click playback
- Footers and slide numbers; presenter view with next slide, notes, timer
- PDF export of slides (searchable text layer) and A4 notes pages; Print
  makes the PDF
- .hydp records and .pptx import/export for all of the above (charts carry
  an embedded workbook); round trips tested through python-pptx and
  LibreOffice Impress fixtures
- Docs and screenshots

Co-Authored-By: Claude Opus 5.5 <noreply@anthropic.com>
Claude-Session: https://claude.ai/code/session_011YNbEw5bpEvU1eNcFnnZWQ
</commit_message>
<xml_diff>
--- a/tests-host/fixtures/slides/office-made.pptx
+++ b/tests-host/fixtures/slides/office-made.pptx
@@ -6,13 +6,13 @@
     <p:sldMasterId id="2147483651" r:id="rId3"/>
     <p:sldMasterId id="2147483653" r:id="rId4"/>
     <p:sldMasterId id="2147483655" r:id="rId5"/>
-    <p:sldMasterId id="2147483657" r:id="rId6"/>
-    <p:sldMasterId id="2147483658" r:id="rId7"/>
-    <p:sldMasterId id="2147483659" r:id="rId8"/>
-    <p:sldMasterId id="2147483660" r:id="rId9"/>
-    <p:sldMasterId id="2147483661" r:id="rId10"/>
-    <p:sldMasterId id="2147483663" r:id="rId11"/>
-    <p:sldMasterId id="2147483664" r:id="rId12"/>
+    <p:sldMasterId id="2147483658" r:id="rId6"/>
+    <p:sldMasterId id="2147483660" r:id="rId7"/>
+    <p:sldMasterId id="2147483662" r:id="rId8"/>
+    <p:sldMasterId id="2147483664" r:id="rId9"/>
+    <p:sldMasterId id="2147483666" r:id="rId10"/>
+    <p:sldMasterId id="2147483668" r:id="rId11"/>
+    <p:sldMasterId id="2147483669" r:id="rId12"/>
   </p:sldMasterIdLst>
   <p:notesMasterIdLst>
     <p:notesMasterId r:id="rId13"/>
@@ -21,10 +21,892 @@
     <p:sldId id="256" r:id="rId14"/>
     <p:sldId id="257" r:id="rId15"/>
     <p:sldId id="258" r:id="rId16"/>
+    <p:sldId id="259" r:id="rId17"/>
   </p:sldIdLst>
   <p:sldSz cx="9144000" cy="6858000"/>
   <p:notesSz cx="6858000" cy="9144000"/>
 </p:presentation>
+</file>
+
+<file path=ppt/charts/chart1.xml><?xml version="1.0" encoding="utf-8"?>
+<c:chartSpace xmlns:c="http://schemas.openxmlformats.org/drawingml/2006/chart" xmlns:a="http://schemas.openxmlformats.org/drawingml/2006/main" xmlns:r="http://schemas.openxmlformats.org/officeDocument/2006/relationships">
+  <c:lang val="en-US"/>
+  <c:roundedCorners val="0"/>
+  <c:chart>
+    <c:autoTitleDeleted val="1"/>
+    <c:plotArea>
+      <c:barChart>
+        <c:barDir val="col"/>
+        <c:grouping val="clustered"/>
+        <c:varyColors val="0"/>
+        <c:ser>
+          <c:idx val="0"/>
+          <c:order val="0"/>
+          <c:tx>
+            <c:strRef>
+              <c:f>label 0</c:f>
+              <c:strCache>
+                <c:ptCount val="1"/>
+                <c:pt idx="0">
+                  <c:v>Q1 Sales</c:v>
+                </c:pt>
+              </c:strCache>
+            </c:strRef>
+          </c:tx>
+          <c:spPr>
+            <a:solidFill>
+              <a:srgbClr val="4f81bd"/>
+            </a:solidFill>
+            <a:ln w="0">
+              <a:noFill/>
+            </a:ln>
+          </c:spPr>
+          <c:invertIfNegative val="0"/>
+          <c:dLbls>
+            <c:txPr>
+              <a:bodyPr wrap="none"/>
+              <a:lstStyle/>
+              <a:p>
+                <a:pPr>
+                  <a:defRPr b="0" sz="1000" spc="-1" strike="noStrike">
+                    <a:solidFill>
+                      <a:srgbClr val="000000"/>
+                    </a:solidFill>
+                    <a:latin typeface="Arial"/>
+                  </a:defRPr>
+                </a:pPr>
+              </a:p>
+            </c:txPr>
+            <c:showLegendKey val="0"/>
+            <c:showVal val="0"/>
+            <c:showCatName val="0"/>
+            <c:showSerName val="0"/>
+            <c:showPercent val="0"/>
+            <c:separator> </c:separator>
+            <c:showLeaderLines val="1"/>
+            <c:extLst>
+              <c:ext xmlns:c15="http://schemas.microsoft.com/office/drawing/2012/chart" uri="{CE6537A1-D6FC-4f65-9D91-7224C49458BB}">
+                <c15:showLeaderLines val="1"/>
+              </c:ext>
+            </c:extLst>
+          </c:dLbls>
+          <c:cat>
+            <c:strRef>
+              <c:f>categories</c:f>
+              <c:strCache>
+                <c:ptCount val="3"/>
+                <c:pt idx="0">
+                  <c:v>East</c:v>
+                </c:pt>
+                <c:pt idx="1">
+                  <c:v>West</c:v>
+                </c:pt>
+                <c:pt idx="2">
+                  <c:v>Midwest</c:v>
+                </c:pt>
+              </c:strCache>
+            </c:strRef>
+          </c:cat>
+          <c:val>
+            <c:numRef>
+              <c:f>0</c:f>
+              <c:numCache>
+                <c:formatCode>General</c:formatCode>
+                <c:ptCount val="3"/>
+                <c:pt idx="0">
+                  <c:v>19.2</c:v>
+                </c:pt>
+                <c:pt idx="1">
+                  <c:v>21.4</c:v>
+                </c:pt>
+                <c:pt idx="2">
+                  <c:v>16.7</c:v>
+                </c:pt>
+              </c:numCache>
+            </c:numRef>
+          </c:val>
+        </c:ser>
+        <c:ser>
+          <c:idx val="1"/>
+          <c:order val="1"/>
+          <c:tx>
+            <c:strRef>
+              <c:f>label 1</c:f>
+              <c:strCache>
+                <c:ptCount val="1"/>
+                <c:pt idx="0">
+                  <c:v>Q2 Sales</c:v>
+                </c:pt>
+              </c:strCache>
+            </c:strRef>
+          </c:tx>
+          <c:spPr>
+            <a:solidFill>
+              <a:srgbClr val="c0504d"/>
+            </a:solidFill>
+            <a:ln w="0">
+              <a:noFill/>
+            </a:ln>
+          </c:spPr>
+          <c:invertIfNegative val="0"/>
+          <c:dLbls>
+            <c:txPr>
+              <a:bodyPr wrap="none"/>
+              <a:lstStyle/>
+              <a:p>
+                <a:pPr>
+                  <a:defRPr b="0" sz="1000" spc="-1" strike="noStrike">
+                    <a:solidFill>
+                      <a:srgbClr val="000000"/>
+                    </a:solidFill>
+                    <a:latin typeface="Arial"/>
+                  </a:defRPr>
+                </a:pPr>
+              </a:p>
+            </c:txPr>
+            <c:showLegendKey val="0"/>
+            <c:showVal val="0"/>
+            <c:showCatName val="0"/>
+            <c:showSerName val="0"/>
+            <c:showPercent val="0"/>
+            <c:separator> </c:separator>
+            <c:showLeaderLines val="1"/>
+            <c:extLst>
+              <c:ext xmlns:c15="http://schemas.microsoft.com/office/drawing/2012/chart" uri="{CE6537A1-D6FC-4f65-9D91-7224C49458BB}">
+                <c15:showLeaderLines val="1"/>
+              </c:ext>
+            </c:extLst>
+          </c:dLbls>
+          <c:cat>
+            <c:strRef>
+              <c:f>categories</c:f>
+              <c:strCache>
+                <c:ptCount val="3"/>
+                <c:pt idx="0">
+                  <c:v>East</c:v>
+                </c:pt>
+                <c:pt idx="1">
+                  <c:v>West</c:v>
+                </c:pt>
+                <c:pt idx="2">
+                  <c:v>Midwest</c:v>
+                </c:pt>
+              </c:strCache>
+            </c:strRef>
+          </c:cat>
+          <c:val>
+            <c:numRef>
+              <c:f>1</c:f>
+              <c:numCache>
+                <c:formatCode>General</c:formatCode>
+                <c:ptCount val="3"/>
+                <c:pt idx="0">
+                  <c:v>22.3</c:v>
+                </c:pt>
+                <c:pt idx="1">
+                  <c:v>28.6</c:v>
+                </c:pt>
+                <c:pt idx="2">
+                  <c:v>15.2</c:v>
+                </c:pt>
+              </c:numCache>
+            </c:numRef>
+          </c:val>
+        </c:ser>
+        <c:gapWidth val="150"/>
+        <c:overlap val="0"/>
+        <c:axId val="62029166"/>
+        <c:axId val="67153898"/>
+      </c:barChart>
+      <c:catAx>
+        <c:axId val="62029166"/>
+        <c:scaling>
+          <c:orientation val="minMax"/>
+        </c:scaling>
+        <c:delete val="0"/>
+        <c:axPos val="b"/>
+        <c:numFmt formatCode="[$-409]mm/dd/yyyy" sourceLinked="1"/>
+        <c:majorTickMark val="out"/>
+        <c:minorTickMark val="none"/>
+        <c:tickLblPos val="nextTo"/>
+        <c:spPr>
+          <a:ln w="9360">
+            <a:solidFill>
+              <a:srgbClr val="878787"/>
+            </a:solidFill>
+            <a:round/>
+          </a:ln>
+        </c:spPr>
+        <c:txPr>
+          <a:bodyPr/>
+          <a:lstStyle/>
+          <a:p>
+            <a:pPr>
+              <a:defRPr b="0" sz="1800" spc="-1" strike="noStrike">
+                <a:solidFill>
+                  <a:srgbClr val="000000"/>
+                </a:solidFill>
+                <a:latin typeface="Calibri"/>
+              </a:defRPr>
+            </a:pPr>
+          </a:p>
+        </c:txPr>
+        <c:crossAx val="67153898"/>
+        <c:crosses val="autoZero"/>
+        <c:auto val="1"/>
+        <c:lblAlgn val="ctr"/>
+        <c:lblOffset val="100"/>
+        <c:noMultiLvlLbl val="0"/>
+      </c:catAx>
+      <c:valAx>
+        <c:axId val="67153898"/>
+        <c:scaling>
+          <c:orientation val="minMax"/>
+        </c:scaling>
+        <c:delete val="0"/>
+        <c:axPos val="l"/>
+        <c:majorGridlines>
+          <c:spPr>
+            <a:ln w="9360">
+              <a:solidFill>
+                <a:srgbClr val="878787"/>
+              </a:solidFill>
+              <a:round/>
+            </a:ln>
+          </c:spPr>
+        </c:majorGridlines>
+        <c:numFmt formatCode="General" sourceLinked="1"/>
+        <c:majorTickMark val="out"/>
+        <c:minorTickMark val="none"/>
+        <c:tickLblPos val="nextTo"/>
+        <c:spPr>
+          <a:ln w="9360">
+            <a:solidFill>
+              <a:srgbClr val="878787"/>
+            </a:solidFill>
+            <a:round/>
+          </a:ln>
+        </c:spPr>
+        <c:txPr>
+          <a:bodyPr/>
+          <a:lstStyle/>
+          <a:p>
+            <a:pPr>
+              <a:defRPr b="0" sz="1800" spc="-1" strike="noStrike">
+                <a:solidFill>
+                  <a:srgbClr val="000000"/>
+                </a:solidFill>
+                <a:latin typeface="Calibri"/>
+              </a:defRPr>
+            </a:pPr>
+          </a:p>
+        </c:txPr>
+        <c:crossAx val="62029166"/>
+        <c:crosses val="autoZero"/>
+        <c:crossBetween val="between"/>
+      </c:valAx>
+      <c:spPr>
+        <a:noFill/>
+        <a:ln w="0">
+          <a:noFill/>
+        </a:ln>
+      </c:spPr>
+    </c:plotArea>
+    <c:plotVisOnly val="1"/>
+    <c:dispBlanksAs val="gap"/>
+  </c:chart>
+  <c:spPr>
+    <a:noFill/>
+    <a:ln w="0">
+      <a:noFill/>
+    </a:ln>
+  </c:spPr>
+</c:chartSpace>
+</file>
+
+<file path=ppt/charts/chart2.xml><?xml version="1.0" encoding="utf-8"?>
+<c:chartSpace xmlns:c="http://schemas.openxmlformats.org/drawingml/2006/chart" xmlns:a="http://schemas.openxmlformats.org/drawingml/2006/main" xmlns:r="http://schemas.openxmlformats.org/officeDocument/2006/relationships">
+  <c:lang val="en-US"/>
+  <c:roundedCorners val="0"/>
+  <c:chart>
+    <c:title>
+      <c:tx>
+        <c:rich>
+          <a:bodyPr rot="0"/>
+          <a:lstStyle/>
+          <a:p>
+            <a:pPr>
+              <a:defRPr b="1" sz="2160" spc="-1" strike="noStrike">
+                <a:solidFill>
+                  <a:srgbClr val="000000"/>
+                </a:solidFill>
+                <a:latin typeface="Calibri"/>
+              </a:defRPr>
+            </a:pPr>
+            <a:r>
+              <a:rPr b="1" sz="2160" spc="-1" strike="noStrike">
+                <a:solidFill>
+                  <a:srgbClr val="000000"/>
+                </a:solidFill>
+                <a:latin typeface="Calibri"/>
+              </a:rPr>
+              <a:t>Share</a:t>
+            </a:r>
+          </a:p>
+        </c:rich>
+      </c:tx>
+      <c:overlay val="0"/>
+      <c:spPr>
+        <a:noFill/>
+        <a:ln w="0">
+          <a:noFill/>
+        </a:ln>
+      </c:spPr>
+    </c:title>
+    <c:autoTitleDeleted val="0"/>
+    <c:plotArea>
+      <c:pieChart>
+        <c:varyColors val="1"/>
+        <c:ser>
+          <c:idx val="0"/>
+          <c:order val="0"/>
+          <c:tx>
+            <c:strRef>
+              <c:f>label 0</c:f>
+              <c:strCache>
+                <c:ptCount val="1"/>
+                <c:pt idx="0">
+                  <c:v>Share</c:v>
+                </c:pt>
+              </c:strCache>
+            </c:strRef>
+          </c:tx>
+          <c:spPr>
+            <a:solidFill>
+              <a:srgbClr val="4f81bd"/>
+            </a:solidFill>
+            <a:ln w="0">
+              <a:noFill/>
+            </a:ln>
+          </c:spPr>
+          <c:explosion val="0"/>
+          <c:dPt>
+            <c:idx val="0"/>
+            <c:spPr>
+              <a:solidFill>
+                <a:srgbClr val="4f81bd"/>
+              </a:solidFill>
+              <a:ln w="0">
+                <a:noFill/>
+              </a:ln>
+            </c:spPr>
+          </c:dPt>
+          <c:dPt>
+            <c:idx val="1"/>
+            <c:spPr>
+              <a:solidFill>
+                <a:srgbClr val="c0504d"/>
+              </a:solidFill>
+              <a:ln w="0">
+                <a:noFill/>
+              </a:ln>
+            </c:spPr>
+          </c:dPt>
+          <c:dPt>
+            <c:idx val="2"/>
+            <c:spPr>
+              <a:solidFill>
+                <a:srgbClr val="9bbb59"/>
+              </a:solidFill>
+              <a:ln w="0">
+                <a:noFill/>
+              </a:ln>
+            </c:spPr>
+          </c:dPt>
+          <c:dLbls>
+            <c:dLbl>
+              <c:idx val="0"/>
+              <c:txPr>
+                <a:bodyPr wrap="none"/>
+                <a:lstStyle/>
+                <a:p>
+                  <a:pPr>
+                    <a:defRPr b="0" sz="1000" spc="-1" strike="noStrike">
+                      <a:solidFill>
+                        <a:srgbClr val="000000"/>
+                      </a:solidFill>
+                      <a:latin typeface="Arial"/>
+                    </a:defRPr>
+                  </a:pPr>
+                </a:p>
+              </c:txPr>
+              <c:showLegendKey val="0"/>
+              <c:showVal val="0"/>
+              <c:showCatName val="0"/>
+              <c:showSerName val="0"/>
+              <c:showPercent val="0"/>
+              <c:separator> </c:separator>
+            </c:dLbl>
+            <c:dLbl>
+              <c:idx val="1"/>
+              <c:txPr>
+                <a:bodyPr wrap="none"/>
+                <a:lstStyle/>
+                <a:p>
+                  <a:pPr>
+                    <a:defRPr b="0" sz="1000" spc="-1" strike="noStrike">
+                      <a:solidFill>
+                        <a:srgbClr val="000000"/>
+                      </a:solidFill>
+                      <a:latin typeface="Arial"/>
+                    </a:defRPr>
+                  </a:pPr>
+                </a:p>
+              </c:txPr>
+              <c:showLegendKey val="0"/>
+              <c:showVal val="0"/>
+              <c:showCatName val="0"/>
+              <c:showSerName val="0"/>
+              <c:showPercent val="0"/>
+              <c:separator> </c:separator>
+            </c:dLbl>
+            <c:dLbl>
+              <c:idx val="2"/>
+              <c:txPr>
+                <a:bodyPr wrap="none"/>
+                <a:lstStyle/>
+                <a:p>
+                  <a:pPr>
+                    <a:defRPr b="0" sz="1000" spc="-1" strike="noStrike">
+                      <a:solidFill>
+                        <a:srgbClr val="000000"/>
+                      </a:solidFill>
+                      <a:latin typeface="Arial"/>
+                    </a:defRPr>
+                  </a:pPr>
+                </a:p>
+              </c:txPr>
+              <c:showLegendKey val="0"/>
+              <c:showVal val="0"/>
+              <c:showCatName val="0"/>
+              <c:showSerName val="0"/>
+              <c:showPercent val="0"/>
+              <c:separator> </c:separator>
+            </c:dLbl>
+            <c:txPr>
+              <a:bodyPr wrap="none"/>
+              <a:lstStyle/>
+              <a:p>
+                <a:pPr>
+                  <a:defRPr b="0" sz="1000" spc="-1" strike="noStrike">
+                    <a:solidFill>
+                      <a:srgbClr val="000000"/>
+                    </a:solidFill>
+                    <a:latin typeface="Arial"/>
+                  </a:defRPr>
+                </a:pPr>
+              </a:p>
+            </c:txPr>
+            <c:showLegendKey val="0"/>
+            <c:showVal val="0"/>
+            <c:showCatName val="0"/>
+            <c:showSerName val="0"/>
+            <c:showPercent val="0"/>
+            <c:separator> </c:separator>
+            <c:showLeaderLines val="1"/>
+          </c:dLbls>
+          <c:cat>
+            <c:strRef>
+              <c:f>categories</c:f>
+              <c:strCache>
+                <c:ptCount val="3"/>
+                <c:pt idx="0">
+                  <c:v>A</c:v>
+                </c:pt>
+                <c:pt idx="1">
+                  <c:v>B</c:v>
+                </c:pt>
+                <c:pt idx="2">
+                  <c:v>C</c:v>
+                </c:pt>
+              </c:strCache>
+            </c:strRef>
+          </c:cat>
+          <c:val>
+            <c:numRef>
+              <c:f>0</c:f>
+              <c:numCache>
+                <c:formatCode>General</c:formatCode>
+                <c:ptCount val="3"/>
+                <c:pt idx="0">
+                  <c:v>50</c:v>
+                </c:pt>
+                <c:pt idx="1">
+                  <c:v>30</c:v>
+                </c:pt>
+                <c:pt idx="2">
+                  <c:v>20</c:v>
+                </c:pt>
+              </c:numCache>
+            </c:numRef>
+          </c:val>
+        </c:ser>
+        <c:firstSliceAng val="0"/>
+      </c:pieChart>
+      <c:spPr>
+        <a:noFill/>
+        <a:ln w="0">
+          <a:noFill/>
+        </a:ln>
+      </c:spPr>
+    </c:plotArea>
+    <c:plotVisOnly val="1"/>
+    <c:dispBlanksAs val="gap"/>
+  </c:chart>
+  <c:spPr>
+    <a:noFill/>
+    <a:ln w="0">
+      <a:noFill/>
+    </a:ln>
+  </c:spPr>
+</c:chartSpace>
+</file>
+
+<file path=ppt/charts/chart3.xml><?xml version="1.0" encoding="utf-8"?>
+<c:chartSpace xmlns:c="http://schemas.openxmlformats.org/drawingml/2006/chart" xmlns:a="http://schemas.openxmlformats.org/drawingml/2006/main" xmlns:r="http://schemas.openxmlformats.org/officeDocument/2006/relationships">
+  <c:lang val="en-US"/>
+  <c:roundedCorners val="0"/>
+  <c:chart>
+    <c:autoTitleDeleted val="1"/>
+    <c:plotArea>
+      <c:lineChart>
+        <c:grouping val="standard"/>
+        <c:varyColors val="0"/>
+        <c:ser>
+          <c:idx val="0"/>
+          <c:order val="0"/>
+          <c:tx>
+            <c:strRef>
+              <c:f>label 0</c:f>
+              <c:strCache>
+                <c:ptCount val="1"/>
+                <c:pt idx="0">
+                  <c:v>Q1 Sales</c:v>
+                </c:pt>
+              </c:strCache>
+            </c:strRef>
+          </c:tx>
+          <c:spPr>
+            <a:solidFill>
+              <a:srgbClr val="4a7ebb"/>
+            </a:solidFill>
+            <a:ln w="28440">
+              <a:solidFill>
+                <a:srgbClr val="4a7ebb"/>
+              </a:solidFill>
+              <a:round/>
+            </a:ln>
+          </c:spPr>
+          <c:marker>
+            <c:symbol val="none"/>
+          </c:marker>
+          <c:dLbls>
+            <c:txPr>
+              <a:bodyPr wrap="none"/>
+              <a:lstStyle/>
+              <a:p>
+                <a:pPr>
+                  <a:defRPr b="0" sz="1000" spc="-1" strike="noStrike">
+                    <a:solidFill>
+                      <a:srgbClr val="000000"/>
+                    </a:solidFill>
+                    <a:latin typeface="Arial"/>
+                  </a:defRPr>
+                </a:pPr>
+              </a:p>
+            </c:txPr>
+            <c:showLegendKey val="0"/>
+            <c:showVal val="0"/>
+            <c:showCatName val="0"/>
+            <c:showSerName val="0"/>
+            <c:showPercent val="0"/>
+            <c:separator> </c:separator>
+            <c:showLeaderLines val="1"/>
+            <c:extLst>
+              <c:ext xmlns:c15="http://schemas.microsoft.com/office/drawing/2012/chart" uri="{CE6537A1-D6FC-4f65-9D91-7224C49458BB}">
+                <c15:showLeaderLines val="1"/>
+              </c:ext>
+            </c:extLst>
+          </c:dLbls>
+          <c:cat>
+            <c:strRef>
+              <c:f>categories</c:f>
+              <c:strCache>
+                <c:ptCount val="3"/>
+                <c:pt idx="0">
+                  <c:v>East</c:v>
+                </c:pt>
+                <c:pt idx="1">
+                  <c:v>West</c:v>
+                </c:pt>
+                <c:pt idx="2">
+                  <c:v>Midwest</c:v>
+                </c:pt>
+              </c:strCache>
+            </c:strRef>
+          </c:cat>
+          <c:val>
+            <c:numRef>
+              <c:f>0</c:f>
+              <c:numCache>
+                <c:formatCode>General</c:formatCode>
+                <c:ptCount val="3"/>
+                <c:pt idx="0">
+                  <c:v>19.2</c:v>
+                </c:pt>
+                <c:pt idx="1">
+                  <c:v>21.4</c:v>
+                </c:pt>
+                <c:pt idx="2">
+                  <c:v>16.7</c:v>
+                </c:pt>
+              </c:numCache>
+            </c:numRef>
+          </c:val>
+          <c:smooth val="0"/>
+        </c:ser>
+        <c:ser>
+          <c:idx val="1"/>
+          <c:order val="1"/>
+          <c:tx>
+            <c:strRef>
+              <c:f>label 1</c:f>
+              <c:strCache>
+                <c:ptCount val="1"/>
+                <c:pt idx="0">
+                  <c:v>Q2 Sales</c:v>
+                </c:pt>
+              </c:strCache>
+            </c:strRef>
+          </c:tx>
+          <c:spPr>
+            <a:solidFill>
+              <a:srgbClr val="be4b48"/>
+            </a:solidFill>
+            <a:ln w="28440">
+              <a:solidFill>
+                <a:srgbClr val="be4b48"/>
+              </a:solidFill>
+              <a:round/>
+            </a:ln>
+          </c:spPr>
+          <c:marker>
+            <c:symbol val="none"/>
+          </c:marker>
+          <c:dLbls>
+            <c:txPr>
+              <a:bodyPr wrap="none"/>
+              <a:lstStyle/>
+              <a:p>
+                <a:pPr>
+                  <a:defRPr b="0" sz="1000" spc="-1" strike="noStrike">
+                    <a:solidFill>
+                      <a:srgbClr val="000000"/>
+                    </a:solidFill>
+                    <a:latin typeface="Arial"/>
+                  </a:defRPr>
+                </a:pPr>
+              </a:p>
+            </c:txPr>
+            <c:showLegendKey val="0"/>
+            <c:showVal val="0"/>
+            <c:showCatName val="0"/>
+            <c:showSerName val="0"/>
+            <c:showPercent val="0"/>
+            <c:separator> </c:separator>
+            <c:showLeaderLines val="1"/>
+            <c:extLst>
+              <c:ext xmlns:c15="http://schemas.microsoft.com/office/drawing/2012/chart" uri="{CE6537A1-D6FC-4f65-9D91-7224C49458BB}">
+                <c15:showLeaderLines val="1"/>
+              </c:ext>
+            </c:extLst>
+          </c:dLbls>
+          <c:cat>
+            <c:strRef>
+              <c:f>categories</c:f>
+              <c:strCache>
+                <c:ptCount val="3"/>
+                <c:pt idx="0">
+                  <c:v>East</c:v>
+                </c:pt>
+                <c:pt idx="1">
+                  <c:v>West</c:v>
+                </c:pt>
+                <c:pt idx="2">
+                  <c:v>Midwest</c:v>
+                </c:pt>
+              </c:strCache>
+            </c:strRef>
+          </c:cat>
+          <c:val>
+            <c:numRef>
+              <c:f>1</c:f>
+              <c:numCache>
+                <c:formatCode>General</c:formatCode>
+                <c:ptCount val="3"/>
+                <c:pt idx="0">
+                  <c:v>22.3</c:v>
+                </c:pt>
+                <c:pt idx="1">
+                  <c:v>28.6</c:v>
+                </c:pt>
+                <c:pt idx="2">
+                  <c:v>15.2</c:v>
+                </c:pt>
+              </c:numCache>
+            </c:numRef>
+          </c:val>
+          <c:smooth val="0"/>
+        </c:ser>
+        <c:hiLowLines>
+          <c:spPr>
+            <a:ln w="0">
+              <a:noFill/>
+            </a:ln>
+          </c:spPr>
+        </c:hiLowLines>
+        <c:marker val="0"/>
+        <c:axId val="82109411"/>
+        <c:axId val="91196367"/>
+      </c:lineChart>
+      <c:catAx>
+        <c:axId val="82109411"/>
+        <c:scaling>
+          <c:orientation val="minMax"/>
+        </c:scaling>
+        <c:delete val="0"/>
+        <c:axPos val="b"/>
+        <c:numFmt formatCode="[$-409]mm/dd/yyyy" sourceLinked="1"/>
+        <c:majorTickMark val="out"/>
+        <c:minorTickMark val="none"/>
+        <c:tickLblPos val="nextTo"/>
+        <c:spPr>
+          <a:ln w="9360">
+            <a:solidFill>
+              <a:srgbClr val="878787"/>
+            </a:solidFill>
+            <a:round/>
+          </a:ln>
+        </c:spPr>
+        <c:txPr>
+          <a:bodyPr/>
+          <a:lstStyle/>
+          <a:p>
+            <a:pPr>
+              <a:defRPr b="0" sz="1800" spc="-1" strike="noStrike">
+                <a:solidFill>
+                  <a:srgbClr val="000000"/>
+                </a:solidFill>
+                <a:latin typeface="Calibri"/>
+              </a:defRPr>
+            </a:pPr>
+          </a:p>
+        </c:txPr>
+        <c:crossAx val="91196367"/>
+        <c:crosses val="autoZero"/>
+        <c:auto val="1"/>
+        <c:lblAlgn val="ctr"/>
+        <c:lblOffset val="100"/>
+        <c:noMultiLvlLbl val="0"/>
+      </c:catAx>
+      <c:valAx>
+        <c:axId val="91196367"/>
+        <c:scaling>
+          <c:orientation val="minMax"/>
+        </c:scaling>
+        <c:delete val="0"/>
+        <c:axPos val="l"/>
+        <c:majorGridlines>
+          <c:spPr>
+            <a:ln w="9360">
+              <a:solidFill>
+                <a:srgbClr val="878787"/>
+              </a:solidFill>
+              <a:round/>
+            </a:ln>
+          </c:spPr>
+        </c:majorGridlines>
+        <c:numFmt formatCode="General" sourceLinked="1"/>
+        <c:majorTickMark val="out"/>
+        <c:minorTickMark val="none"/>
+        <c:tickLblPos val="nextTo"/>
+        <c:spPr>
+          <a:ln w="9360">
+            <a:solidFill>
+              <a:srgbClr val="878787"/>
+            </a:solidFill>
+            <a:round/>
+          </a:ln>
+        </c:spPr>
+        <c:txPr>
+          <a:bodyPr/>
+          <a:lstStyle/>
+          <a:p>
+            <a:pPr>
+              <a:defRPr b="0" sz="1800" spc="-1" strike="noStrike">
+                <a:solidFill>
+                  <a:srgbClr val="000000"/>
+                </a:solidFill>
+                <a:latin typeface="Calibri"/>
+              </a:defRPr>
+            </a:pPr>
+          </a:p>
+        </c:txPr>
+        <c:crossAx val="82109411"/>
+        <c:crosses val="autoZero"/>
+        <c:crossBetween val="between"/>
+      </c:valAx>
+      <c:spPr>
+        <a:noFill/>
+        <a:ln w="0">
+          <a:noFill/>
+        </a:ln>
+      </c:spPr>
+    </c:plotArea>
+    <c:legend>
+      <c:legendPos val="r"/>
+      <c:overlay val="0"/>
+      <c:spPr>
+        <a:noFill/>
+        <a:ln w="0">
+          <a:noFill/>
+        </a:ln>
+      </c:spPr>
+      <c:txPr>
+        <a:bodyPr/>
+        <a:lstStyle/>
+        <a:p>
+          <a:pPr>
+            <a:defRPr b="0" sz="1800" spc="-1" strike="noStrike">
+              <a:solidFill>
+                <a:srgbClr val="000000"/>
+              </a:solidFill>
+              <a:latin typeface="Calibri"/>
+            </a:defRPr>
+          </a:pPr>
+        </a:p>
+      </c:txPr>
+    </c:legend>
+    <c:plotVisOnly val="1"/>
+    <c:dispBlanksAs val="gap"/>
+  </c:chart>
+  <c:spPr>
+    <a:noFill/>
+    <a:ln w="0">
+      <a:noFill/>
+    </a:ln>
+  </c:spPr>
+</c:chartSpace>
 </file>
 
 <file path=ppt/notesMasters/notesMaster1.xml><?xml version="1.0" encoding="utf-8"?>
@@ -46,7 +928,7 @@
       </p:grpSpPr>
       <p:sp>
         <p:nvSpPr>
-          <p:cNvPr id="70" name="PlaceHolder 1"/>
+          <p:cNvPr id="73" name="PlaceHolder 1"/>
           <p:cNvSpPr>
             <a:spLocks noGrp="1"/>
           </p:cNvSpPr>
@@ -92,7 +974,7 @@
       </p:sp>
       <p:sp>
         <p:nvSpPr>
-          <p:cNvPr id="71" name="PlaceHolder 2"/>
+          <p:cNvPr id="74" name="PlaceHolder 2"/>
           <p:cNvSpPr>
             <a:spLocks noGrp="1"/>
           </p:cNvSpPr>
@@ -141,7 +1023,7 @@
       </p:sp>
       <p:sp>
         <p:nvSpPr>
-          <p:cNvPr id="72" name="PlaceHolder 3"/>
+          <p:cNvPr id="75" name="PlaceHolder 3"/>
           <p:cNvSpPr>
             <a:spLocks noGrp="1"/>
           </p:cNvSpPr>
@@ -190,7 +1072,7 @@
       </p:sp>
       <p:sp>
         <p:nvSpPr>
-          <p:cNvPr id="73" name="PlaceHolder 4"/>
+          <p:cNvPr id="76" name="PlaceHolder 4"/>
           <p:cNvSpPr>
             <a:spLocks noGrp="1"/>
           </p:cNvSpPr>
@@ -250,7 +1132,7 @@
       </p:sp>
       <p:sp>
         <p:nvSpPr>
-          <p:cNvPr id="74" name="PlaceHolder 5"/>
+          <p:cNvPr id="77" name="PlaceHolder 5"/>
           <p:cNvSpPr>
             <a:spLocks noGrp="1"/>
           </p:cNvSpPr>
@@ -310,7 +1192,7 @@
       </p:sp>
       <p:sp>
         <p:nvSpPr>
-          <p:cNvPr id="75" name="PlaceHolder 6"/>
+          <p:cNvPr id="78" name="PlaceHolder 6"/>
           <p:cNvSpPr>
             <a:spLocks noGrp="1"/>
           </p:cNvSpPr>
@@ -350,7 +1232,7 @@
             <a:pPr indent="0" algn="r">
               <a:buNone/>
             </a:pPr>
-            <a:fld id="{BAFFEB43-7EAC-4217-8DFD-6D2386932321}" type="slidenum">
+            <a:fld id="{6D3AFAA1-0CAF-465F-9B03-08ACE5503C6B}" type="slidenum">
               <a:rPr b="0" lang="en-US" sz="1400" spc="-1" strike="noStrike">
                 <a:solidFill>
                   <a:srgbClr val="000000"/>
@@ -393,7 +1275,7 @@
       </p:grpSpPr>
       <p:sp>
         <p:nvSpPr>
-          <p:cNvPr id="87" name="PlaceHolder 1"/>
+          <p:cNvPr id="98" name="PlaceHolder 1"/>
           <p:cNvSpPr>
             <a:spLocks noGrp="1"/>
           </p:cNvSpPr>
@@ -416,7 +1298,7 @@
       </p:sp>
       <p:sp>
         <p:nvSpPr>
-          <p:cNvPr id="88" name="PlaceHolder 2"/>
+          <p:cNvPr id="99" name="PlaceHolder 2"/>
           <p:cNvSpPr>
             <a:spLocks noGrp="1"/>
           </p:cNvSpPr>
@@ -491,7 +1373,7 @@
       </p:sp>
       <p:sp>
         <p:nvSpPr>
-          <p:cNvPr id="89" name="PlaceHolder 3"/>
+          <p:cNvPr id="100" name="PlaceHolder 3"/>
           <p:cNvSpPr>
             <a:spLocks noGrp="1"/>
           </p:cNvSpPr>
@@ -537,7 +1419,7 @@
               </a:lnSpc>
               <a:buNone/>
             </a:pPr>
-            <a:fld id="{715ECED2-E44A-442A-95FE-C62483E539C8}" type="slidenum">
+            <a:fld id="{D7625C76-6C5B-42ED-BDD4-98C4B5C252FB}" type="slidenum">
               <a:rPr b="0" lang="en-US" sz="1200" spc="-1" strike="noStrike">
                 <a:solidFill>
                   <a:srgbClr val="000000"/>
@@ -561,7 +1443,7 @@
 </file>
 
 <file path=ppt/slideLayouts/slideLayout1.xml><?xml version="1.0" encoding="utf-8"?>
-<p:sldLayout xmlns:a="http://schemas.openxmlformats.org/drawingml/2006/main" xmlns:p="http://schemas.openxmlformats.org/presentationml/2006/main" xmlns:r="http://schemas.openxmlformats.org/officeDocument/2006/relationships" xmlns:p14="http://schemas.microsoft.com/office/powerpoint/2010/main" xmlns:p15="http://schemas.microsoft.com/office/powerpoint/2012/main" xmlns:mc="http://schemas.openxmlformats.org/markup-compatibility/2006" type="obj" preserve="1">
+<p:sldLayout xmlns:a="http://schemas.openxmlformats.org/drawingml/2006/main" xmlns:p="http://schemas.openxmlformats.org/presentationml/2006/main" xmlns:r="http://schemas.openxmlformats.org/officeDocument/2006/relationships" xmlns:p14="http://schemas.microsoft.com/office/powerpoint/2010/main" xmlns:p15="http://schemas.microsoft.com/office/powerpoint/2012/main" xmlns:mc="http://schemas.openxmlformats.org/markup-compatibility/2006" type="titleOnly" preserve="1">
   <p:cSld name="Title Slide">
     <p:spTree>
       <p:nvGrpSpPr>
@@ -589,8 +1471,8 @@
         </p:nvSpPr>
         <p:spPr>
           <a:xfrm>
-            <a:off x="457200" y="273600"/>
-            <a:ext cx="8229240" cy="1144800"/>
+            <a:off x="457200" y="274680"/>
+            <a:ext cx="8229240" cy="1142640"/>
           </a:xfrm>
           <a:prstGeom prst="rect">
             <a:avLst/>
@@ -619,18 +1501,101 @@
       </p:sp>
       <p:sp>
         <p:nvSpPr>
-          <p:cNvPr id="6" name="PlaceHolder 2"/>
-          <p:cNvSpPr>
-            <a:spLocks noGrp="1"/>
-          </p:cNvSpPr>
-          <p:nvPr>
-            <p:ph/>
+          <p:cNvPr id="3" name="PlaceHolder 2"/>
+          <p:cNvSpPr>
+            <a:spLocks noGrp="1"/>
+          </p:cNvSpPr>
+          <p:nvPr>
+            <p:ph type="ftr" idx="2"/>
+          </p:nvPr>
+        </p:nvSpPr>
+        <p:spPr/>
+        <p:txBody>
+          <a:bodyPr/>
+          <a:p>
+            <a:r>
+              <a:t>Footer</a:t>
+            </a:r>
+          </a:p>
+        </p:txBody>
+      </p:sp>
+      <p:sp>
+        <p:nvSpPr>
+          <p:cNvPr id="4" name="PlaceHolder 3"/>
+          <p:cNvSpPr>
+            <a:spLocks noGrp="1"/>
+          </p:cNvSpPr>
+          <p:nvPr>
+            <p:ph type="sldNum" idx="3"/>
+          </p:nvPr>
+        </p:nvSpPr>
+        <p:spPr/>
+        <p:txBody>
+          <a:bodyPr/>
+          <a:p>
+            <a:fld id="{536E92AD-1E1D-46F2-B314-600BD18AD2B2}" type="slidenum">
+              <a:t>&lt;#&gt;</a:t>
+            </a:fld>
+          </a:p>
+        </p:txBody>
+      </p:sp>
+      <p:sp>
+        <p:nvSpPr>
+          <p:cNvPr id="5" name="PlaceHolder 4"/>
+          <p:cNvSpPr>
+            <a:spLocks noGrp="1"/>
+          </p:cNvSpPr>
+          <p:nvPr>
+            <p:ph type="dt" idx="1"/>
+          </p:nvPr>
+        </p:nvSpPr>
+        <p:spPr/>
+        <p:txBody>
+          <a:bodyPr/>
+          <a:p>
+            <a:r>
+              <a:rPr lang="en-US"/>
+              <a:t/>
+            </a:r>
+          </a:p>
+        </p:txBody>
+      </p:sp>
+    </p:spTree>
+  </p:cSld>
+</p:sldLayout>
+</file>
+
+<file path=ppt/slideLayouts/slideLayout10.xml><?xml version="1.0" encoding="utf-8"?>
+<p:sldLayout xmlns:a="http://schemas.openxmlformats.org/drawingml/2006/main" xmlns:p="http://schemas.openxmlformats.org/presentationml/2006/main" xmlns:r="http://schemas.openxmlformats.org/officeDocument/2006/relationships" xmlns:p14="http://schemas.microsoft.com/office/powerpoint/2010/main" xmlns:p15="http://schemas.microsoft.com/office/powerpoint/2012/main" xmlns:mc="http://schemas.openxmlformats.org/markup-compatibility/2006" type="titleOnly" preserve="1">
+  <p:cSld name="Title Only">
+    <p:spTree>
+      <p:nvGrpSpPr>
+        <p:cNvPr id="1" name=""/>
+        <p:cNvGrpSpPr/>
+        <p:nvPr/>
+      </p:nvGrpSpPr>
+      <p:grpSpPr>
+        <a:xfrm>
+          <a:off x="0" y="0"/>
+          <a:ext cx="0" cy="0"/>
+          <a:chOff x="0" y="0"/>
+          <a:chExt cx="0" cy="0"/>
+        </a:xfrm>
+      </p:grpSpPr>
+      <p:sp>
+        <p:nvSpPr>
+          <p:cNvPr id="55" name="PlaceHolder 1"/>
+          <p:cNvSpPr>
+            <a:spLocks noGrp="1"/>
+          </p:cNvSpPr>
+          <p:nvPr>
+            <p:ph type="title"/>
           </p:nvPr>
         </p:nvSpPr>
         <p:spPr>
           <a:xfrm>
-            <a:off x="457200" y="1604520"/>
-            <a:ext cx="8229240" cy="3977280"/>
+            <a:off x="457200" y="274680"/>
+            <a:ext cx="8229240" cy="1142640"/>
           </a:xfrm>
           <a:prstGeom prst="rect">
             <a:avLst/>
@@ -641,17 +1606,14 @@
           </a:ln>
         </p:spPr>
         <p:txBody>
-          <a:bodyPr lIns="0" rIns="0" tIns="0" bIns="0" anchor="t">
-            <a:normAutofit/>
+          <a:bodyPr lIns="0" rIns="0" tIns="0" bIns="0" anchor="ctr">
+            <a:noAutofit/>
           </a:bodyPr>
           <a:p>
             <a:pPr indent="0">
-              <a:spcBef>
-                <a:spcPts val="1417"/>
-              </a:spcBef>
               <a:buNone/>
             </a:pPr>
-            <a:endParaRPr b="0" lang="en-US" sz="3200" spc="-1" strike="noStrike">
+            <a:endParaRPr b="0" lang="en-US" sz="1800" spc="-1" strike="noStrike">
               <a:solidFill>
                 <a:schemeClr val="dk1"/>
               </a:solidFill>
@@ -662,39 +1624,39 @@
       </p:sp>
       <p:sp>
         <p:nvSpPr>
+          <p:cNvPr id="3" name="PlaceHolder 2"/>
+          <p:cNvSpPr>
+            <a:spLocks noGrp="1"/>
+          </p:cNvSpPr>
+          <p:nvPr>
+            <p:ph type="ftr" idx="23"/>
+          </p:nvPr>
+        </p:nvSpPr>
+        <p:spPr/>
+        <p:txBody>
+          <a:bodyPr/>
+          <a:p>
+            <a:r>
+              <a:t>Footer</a:t>
+            </a:r>
+          </a:p>
+        </p:txBody>
+      </p:sp>
+      <p:sp>
+        <p:nvSpPr>
           <p:cNvPr id="4" name="PlaceHolder 3"/>
           <p:cNvSpPr>
             <a:spLocks noGrp="1"/>
           </p:cNvSpPr>
           <p:nvPr>
-            <p:ph type="ftr" idx="2"/>
+            <p:ph type="sldNum" idx="24"/>
           </p:nvPr>
         </p:nvSpPr>
         <p:spPr/>
         <p:txBody>
           <a:bodyPr/>
           <a:p>
-            <a:r>
-              <a:t>Footer</a:t>
-            </a:r>
-          </a:p>
-        </p:txBody>
-      </p:sp>
-      <p:sp>
-        <p:nvSpPr>
-          <p:cNvPr id="5" name="PlaceHolder 4"/>
-          <p:cNvSpPr>
-            <a:spLocks noGrp="1"/>
-          </p:cNvSpPr>
-          <p:nvPr>
-            <p:ph type="sldNum" idx="3"/>
-          </p:nvPr>
-        </p:nvSpPr>
-        <p:spPr/>
-        <p:txBody>
-          <a:bodyPr/>
-          <a:p>
-            <a:fld id="{E2D0A4D0-4358-4EDC-97D0-1B0828334F6A}" type="slidenum">
+            <a:fld id="{FCE58BCA-7C02-4AB2-A5B6-929575F7F651}" type="slidenum">
               <a:t>&lt;#&gt;</a:t>
             </a:fld>
           </a:p>
@@ -702,12 +1664,95 @@
       </p:sp>
       <p:sp>
         <p:nvSpPr>
-          <p:cNvPr id="6" name="PlaceHolder 5"/>
-          <p:cNvSpPr>
-            <a:spLocks noGrp="1"/>
-          </p:cNvSpPr>
-          <p:nvPr>
-            <p:ph type="dt" idx="1"/>
+          <p:cNvPr id="5" name="PlaceHolder 4"/>
+          <p:cNvSpPr>
+            <a:spLocks noGrp="1"/>
+          </p:cNvSpPr>
+          <p:nvPr>
+            <p:ph type="dt" idx="22"/>
+          </p:nvPr>
+        </p:nvSpPr>
+        <p:spPr/>
+        <p:txBody>
+          <a:bodyPr/>
+          <a:p>
+            <a:r>
+              <a:rPr lang="en-US"/>
+              <a:t/>
+            </a:r>
+          </a:p>
+        </p:txBody>
+      </p:sp>
+    </p:spTree>
+  </p:cSld>
+</p:sldLayout>
+</file>
+
+<file path=ppt/slideLayouts/slideLayout11.xml><?xml version="1.0" encoding="utf-8"?>
+<p:sldLayout xmlns:a="http://schemas.openxmlformats.org/drawingml/2006/main" xmlns:p="http://schemas.openxmlformats.org/presentationml/2006/main" xmlns:r="http://schemas.openxmlformats.org/officeDocument/2006/relationships" xmlns:p14="http://schemas.microsoft.com/office/powerpoint/2010/main" xmlns:p15="http://schemas.microsoft.com/office/powerpoint/2012/main" xmlns:mc="http://schemas.openxmlformats.org/markup-compatibility/2006" type="blank" preserve="1">
+  <p:cSld name="Blank">
+    <p:spTree>
+      <p:nvGrpSpPr>
+        <p:cNvPr id="1" name=""/>
+        <p:cNvGrpSpPr/>
+        <p:nvPr/>
+      </p:nvGrpSpPr>
+      <p:grpSpPr>
+        <a:xfrm>
+          <a:off x="0" y="0"/>
+          <a:ext cx="0" cy="0"/>
+          <a:chOff x="0" y="0"/>
+          <a:chExt cx="0" cy="0"/>
+        </a:xfrm>
+      </p:grpSpPr>
+      <p:sp>
+        <p:nvSpPr>
+          <p:cNvPr id="2" name="PlaceHolder 1"/>
+          <p:cNvSpPr>
+            <a:spLocks noGrp="1"/>
+          </p:cNvSpPr>
+          <p:nvPr>
+            <p:ph type="ftr" idx="26"/>
+          </p:nvPr>
+        </p:nvSpPr>
+        <p:spPr/>
+        <p:txBody>
+          <a:bodyPr/>
+          <a:p>
+            <a:r>
+              <a:t>Footer</a:t>
+            </a:r>
+          </a:p>
+        </p:txBody>
+      </p:sp>
+      <p:sp>
+        <p:nvSpPr>
+          <p:cNvPr id="3" name="PlaceHolder 2"/>
+          <p:cNvSpPr>
+            <a:spLocks noGrp="1"/>
+          </p:cNvSpPr>
+          <p:nvPr>
+            <p:ph type="sldNum" idx="27"/>
+          </p:nvPr>
+        </p:nvSpPr>
+        <p:spPr/>
+        <p:txBody>
+          <a:bodyPr/>
+          <a:p>
+            <a:fld id="{169F42CA-853A-420C-9197-4F6F28D2725A}" type="slidenum">
+              <a:t>&lt;#&gt;</a:t>
+            </a:fld>
+          </a:p>
+        </p:txBody>
+      </p:sp>
+      <p:sp>
+        <p:nvSpPr>
+          <p:cNvPr id="4" name="PlaceHolder 3"/>
+          <p:cNvSpPr>
+            <a:spLocks noGrp="1"/>
+          </p:cNvSpPr>
+          <p:nvPr>
+            <p:ph type="dt" idx="25"/>
           </p:nvPr>
         </p:nvSpPr>
         <p:spPr/>
@@ -745,7 +1790,7 @@
       </p:grpSpPr>
       <p:sp>
         <p:nvSpPr>
-          <p:cNvPr id="7" name="PlaceHolder 1"/>
+          <p:cNvPr id="6" name="PlaceHolder 1"/>
           <p:cNvSpPr>
             <a:spLocks noGrp="1"/>
           </p:cNvSpPr>
@@ -755,8 +1800,8 @@
         </p:nvSpPr>
         <p:spPr>
           <a:xfrm>
-            <a:off x="457200" y="273600"/>
-            <a:ext cx="8229240" cy="1144800"/>
+            <a:off x="457200" y="274680"/>
+            <a:ext cx="8229240" cy="1142640"/>
           </a:xfrm>
           <a:prstGeom prst="rect">
             <a:avLst/>
@@ -785,7 +1830,7 @@
       </p:sp>
       <p:sp>
         <p:nvSpPr>
-          <p:cNvPr id="8" name="PlaceHolder 2"/>
+          <p:cNvPr id="7" name="PlaceHolder 2"/>
           <p:cNvSpPr>
             <a:spLocks noGrp="1"/>
           </p:cNvSpPr>
@@ -857,7 +1902,7 @@
         <p:txBody>
           <a:bodyPr/>
           <a:p>
-            <a:fld id="{9F8E7356-23FC-431A-8B2B-8B3B6408EF1D}" type="slidenum">
+            <a:fld id="{F5FD0070-0913-4955-8756-99D08C3DF301}" type="slidenum">
               <a:t>&lt;#&gt;</a:t>
             </a:fld>
           </a:p>
@@ -890,7 +1935,7 @@
 </file>
 
 <file path=ppt/slideLayouts/slideLayout3.xml><?xml version="1.0" encoding="utf-8"?>
-<p:sldLayout xmlns:a="http://schemas.openxmlformats.org/drawingml/2006/main" xmlns:p="http://schemas.openxmlformats.org/presentationml/2006/main" xmlns:r="http://schemas.openxmlformats.org/officeDocument/2006/relationships" xmlns:p14="http://schemas.microsoft.com/office/powerpoint/2010/main" xmlns:p15="http://schemas.microsoft.com/office/powerpoint/2012/main" xmlns:mc="http://schemas.openxmlformats.org/markup-compatibility/2006" type="obj" preserve="1">
+<p:sldLayout xmlns:a="http://schemas.openxmlformats.org/drawingml/2006/main" xmlns:p="http://schemas.openxmlformats.org/presentationml/2006/main" xmlns:r="http://schemas.openxmlformats.org/officeDocument/2006/relationships" xmlns:p14="http://schemas.microsoft.com/office/powerpoint/2010/main" xmlns:p15="http://schemas.microsoft.com/office/powerpoint/2012/main" xmlns:mc="http://schemas.openxmlformats.org/markup-compatibility/2006" type="titleOnly" preserve="1">
   <p:cSld name="Title and Vertical Text">
     <p:spTree>
       <p:nvGrpSpPr>
@@ -908,7 +1953,7 @@
       </p:grpSpPr>
       <p:sp>
         <p:nvSpPr>
-          <p:cNvPr id="14" name="PlaceHolder 1"/>
+          <p:cNvPr id="13" name="PlaceHolder 1"/>
           <p:cNvSpPr>
             <a:spLocks noGrp="1"/>
           </p:cNvSpPr>
@@ -918,8 +1963,8 @@
         </p:nvSpPr>
         <p:spPr>
           <a:xfrm>
-            <a:off x="457200" y="273600"/>
-            <a:ext cx="8229240" cy="1144800"/>
+            <a:off x="457200" y="274680"/>
+            <a:ext cx="8229240" cy="1142640"/>
           </a:xfrm>
           <a:prstGeom prst="rect">
             <a:avLst/>
@@ -948,44 +1993,21 @@
       </p:sp>
       <p:sp>
         <p:nvSpPr>
-          <p:cNvPr id="15" name="PlaceHolder 2"/>
-          <p:cNvSpPr>
-            <a:spLocks noGrp="1"/>
-          </p:cNvSpPr>
-          <p:nvPr>
-            <p:ph/>
-          </p:nvPr>
-        </p:nvSpPr>
-        <p:spPr>
-          <a:xfrm>
-            <a:off x="457200" y="1604520"/>
-            <a:ext cx="8229240" cy="3977280"/>
-          </a:xfrm>
-          <a:prstGeom prst="rect">
-            <a:avLst/>
-          </a:prstGeom>
-          <a:noFill/>
-          <a:ln w="0">
-            <a:noFill/>
-          </a:ln>
-        </p:spPr>
-        <p:txBody>
-          <a:bodyPr lIns="0" rIns="0" tIns="0" bIns="0" anchor="t">
-            <a:normAutofit/>
-          </a:bodyPr>
-          <a:p>
-            <a:pPr indent="0">
-              <a:spcBef>
-                <a:spcPts val="1417"/>
-              </a:spcBef>
-              <a:buNone/>
-            </a:pPr>
-            <a:endParaRPr b="0" lang="en-US" sz="3200" spc="-1" strike="noStrike">
-              <a:solidFill>
-                <a:schemeClr val="dk1"/>
-              </a:solidFill>
-              <a:latin typeface="Calibri"/>
-            </a:endParaRPr>
+          <p:cNvPr id="3" name="PlaceHolder 2"/>
+          <p:cNvSpPr>
+            <a:spLocks noGrp="1"/>
+          </p:cNvSpPr>
+          <p:nvPr>
+            <p:ph type="ftr" idx="5"/>
+          </p:nvPr>
+        </p:nvSpPr>
+        <p:spPr/>
+        <p:txBody>
+          <a:bodyPr/>
+          <a:p>
+            <a:r>
+              <a:t>Footer</a:t>
+            </a:r>
           </a:p>
         </p:txBody>
       </p:sp>
@@ -996,34 +2018,14 @@
             <a:spLocks noGrp="1"/>
           </p:cNvSpPr>
           <p:nvPr>
-            <p:ph type="ftr" idx="5"/>
+            <p:ph type="sldNum" idx="6"/>
           </p:nvPr>
         </p:nvSpPr>
         <p:spPr/>
         <p:txBody>
           <a:bodyPr/>
           <a:p>
-            <a:r>
-              <a:t>Footer</a:t>
-            </a:r>
-          </a:p>
-        </p:txBody>
-      </p:sp>
-      <p:sp>
-        <p:nvSpPr>
-          <p:cNvPr id="5" name="PlaceHolder 4"/>
-          <p:cNvSpPr>
-            <a:spLocks noGrp="1"/>
-          </p:cNvSpPr>
-          <p:nvPr>
-            <p:ph type="sldNum" idx="6"/>
-          </p:nvPr>
-        </p:nvSpPr>
-        <p:spPr/>
-        <p:txBody>
-          <a:bodyPr/>
-          <a:p>
-            <a:fld id="{99DDEC16-B7F7-46BD-9C3C-008EFF6A3682}" type="slidenum">
+            <a:fld id="{DBADC502-F2EA-42AA-95B7-B5E83C2DF1EF}" type="slidenum">
               <a:t>&lt;#&gt;</a:t>
             </a:fld>
           </a:p>
@@ -1031,7 +2033,7 @@
       </p:sp>
       <p:sp>
         <p:nvSpPr>
-          <p:cNvPr id="6" name="PlaceHolder 5"/>
+          <p:cNvPr id="5" name="PlaceHolder 4"/>
           <p:cNvSpPr>
             <a:spLocks noGrp="1"/>
           </p:cNvSpPr>
@@ -1056,7 +2058,7 @@
 </file>
 
 <file path=ppt/slideLayouts/slideLayout4.xml><?xml version="1.0" encoding="utf-8"?>
-<p:sldLayout xmlns:a="http://schemas.openxmlformats.org/drawingml/2006/main" xmlns:p="http://schemas.openxmlformats.org/presentationml/2006/main" xmlns:r="http://schemas.openxmlformats.org/officeDocument/2006/relationships" xmlns:p14="http://schemas.microsoft.com/office/powerpoint/2010/main" xmlns:p15="http://schemas.microsoft.com/office/powerpoint/2012/main" xmlns:mc="http://schemas.openxmlformats.org/markup-compatibility/2006" type="obj" preserve="1">
+<p:sldLayout xmlns:a="http://schemas.openxmlformats.org/drawingml/2006/main" xmlns:p="http://schemas.openxmlformats.org/presentationml/2006/main" xmlns:r="http://schemas.openxmlformats.org/officeDocument/2006/relationships" xmlns:p14="http://schemas.microsoft.com/office/powerpoint/2010/main" xmlns:p15="http://schemas.microsoft.com/office/powerpoint/2012/main" xmlns:mc="http://schemas.openxmlformats.org/markup-compatibility/2006" type="titleOnly" preserve="1">
   <p:cSld name="Vertical Title and Text">
     <p:spTree>
       <p:nvGrpSpPr>
@@ -1074,7 +2076,7 @@
       </p:grpSpPr>
       <p:sp>
         <p:nvSpPr>
-          <p:cNvPr id="21" name="PlaceHolder 1"/>
+          <p:cNvPr id="19" name="PlaceHolder 1"/>
           <p:cNvSpPr>
             <a:spLocks noGrp="1"/>
           </p:cNvSpPr>
@@ -1084,8 +2086,8 @@
         </p:nvSpPr>
         <p:spPr>
           <a:xfrm>
-            <a:off x="457200" y="273600"/>
-            <a:ext cx="8229240" cy="1144800"/>
+            <a:off x="457200" y="274680"/>
+            <a:ext cx="8229240" cy="1142640"/>
           </a:xfrm>
           <a:prstGeom prst="rect">
             <a:avLst/>
@@ -1114,18 +2116,101 @@
       </p:sp>
       <p:sp>
         <p:nvSpPr>
-          <p:cNvPr id="22" name="PlaceHolder 2"/>
-          <p:cNvSpPr>
-            <a:spLocks noGrp="1"/>
-          </p:cNvSpPr>
-          <p:nvPr>
-            <p:ph/>
+          <p:cNvPr id="3" name="PlaceHolder 2"/>
+          <p:cNvSpPr>
+            <a:spLocks noGrp="1"/>
+          </p:cNvSpPr>
+          <p:nvPr>
+            <p:ph type="ftr" idx="8"/>
+          </p:nvPr>
+        </p:nvSpPr>
+        <p:spPr/>
+        <p:txBody>
+          <a:bodyPr/>
+          <a:p>
+            <a:r>
+              <a:t>Footer</a:t>
+            </a:r>
+          </a:p>
+        </p:txBody>
+      </p:sp>
+      <p:sp>
+        <p:nvSpPr>
+          <p:cNvPr id="4" name="PlaceHolder 3"/>
+          <p:cNvSpPr>
+            <a:spLocks noGrp="1"/>
+          </p:cNvSpPr>
+          <p:nvPr>
+            <p:ph type="sldNum" idx="9"/>
+          </p:nvPr>
+        </p:nvSpPr>
+        <p:spPr/>
+        <p:txBody>
+          <a:bodyPr/>
+          <a:p>
+            <a:fld id="{47049008-166F-4C8A-8222-8521AC16FB24}" type="slidenum">
+              <a:t>&lt;#&gt;</a:t>
+            </a:fld>
+          </a:p>
+        </p:txBody>
+      </p:sp>
+      <p:sp>
+        <p:nvSpPr>
+          <p:cNvPr id="5" name="PlaceHolder 4"/>
+          <p:cNvSpPr>
+            <a:spLocks noGrp="1"/>
+          </p:cNvSpPr>
+          <p:nvPr>
+            <p:ph type="dt" idx="7"/>
+          </p:nvPr>
+        </p:nvSpPr>
+        <p:spPr/>
+        <p:txBody>
+          <a:bodyPr/>
+          <a:p>
+            <a:r>
+              <a:rPr lang="en-US"/>
+              <a:t/>
+            </a:r>
+          </a:p>
+        </p:txBody>
+      </p:sp>
+    </p:spTree>
+  </p:cSld>
+</p:sldLayout>
+</file>
+
+<file path=ppt/slideLayouts/slideLayout5.xml><?xml version="1.0" encoding="utf-8"?>
+<p:sldLayout xmlns:a="http://schemas.openxmlformats.org/drawingml/2006/main" xmlns:p="http://schemas.openxmlformats.org/presentationml/2006/main" xmlns:r="http://schemas.openxmlformats.org/officeDocument/2006/relationships" xmlns:p14="http://schemas.microsoft.com/office/powerpoint/2010/main" xmlns:p15="http://schemas.microsoft.com/office/powerpoint/2012/main" xmlns:mc="http://schemas.openxmlformats.org/markup-compatibility/2006" type="titleOnly" preserve="1">
+  <p:cSld name="Title and Content">
+    <p:spTree>
+      <p:nvGrpSpPr>
+        <p:cNvPr id="1" name=""/>
+        <p:cNvGrpSpPr/>
+        <p:nvPr/>
+      </p:nvGrpSpPr>
+      <p:grpSpPr>
+        <a:xfrm>
+          <a:off x="0" y="0"/>
+          <a:ext cx="0" cy="0"/>
+          <a:chOff x="0" y="0"/>
+          <a:chExt cx="0" cy="0"/>
+        </a:xfrm>
+      </p:grpSpPr>
+      <p:sp>
+        <p:nvSpPr>
+          <p:cNvPr id="25" name="PlaceHolder 1"/>
+          <p:cNvSpPr>
+            <a:spLocks noGrp="1"/>
+          </p:cNvSpPr>
+          <p:nvPr>
+            <p:ph type="title"/>
           </p:nvPr>
         </p:nvSpPr>
         <p:spPr>
           <a:xfrm>
-            <a:off x="457200" y="1604520"/>
-            <a:ext cx="8229240" cy="3977280"/>
+            <a:off x="457200" y="274680"/>
+            <a:ext cx="8229240" cy="1142640"/>
           </a:xfrm>
           <a:prstGeom prst="rect">
             <a:avLst/>
@@ -1136,17 +2221,14 @@
           </a:ln>
         </p:spPr>
         <p:txBody>
-          <a:bodyPr lIns="0" rIns="0" tIns="0" bIns="0" anchor="t">
-            <a:normAutofit/>
+          <a:bodyPr lIns="0" rIns="0" tIns="0" bIns="0" anchor="ctr">
+            <a:noAutofit/>
           </a:bodyPr>
           <a:p>
             <a:pPr indent="0">
-              <a:spcBef>
-                <a:spcPts val="1417"/>
-              </a:spcBef>
               <a:buNone/>
             </a:pPr>
-            <a:endParaRPr b="0" lang="en-US" sz="3200" spc="-1" strike="noStrike">
+            <a:endParaRPr b="0" lang="en-US" sz="1800" spc="-1" strike="noStrike">
               <a:solidFill>
                 <a:schemeClr val="dk1"/>
               </a:solidFill>
@@ -1157,39 +2239,39 @@
       </p:sp>
       <p:sp>
         <p:nvSpPr>
+          <p:cNvPr id="3" name="PlaceHolder 2"/>
+          <p:cNvSpPr>
+            <a:spLocks noGrp="1"/>
+          </p:cNvSpPr>
+          <p:nvPr>
+            <p:ph type="ftr" idx="11"/>
+          </p:nvPr>
+        </p:nvSpPr>
+        <p:spPr/>
+        <p:txBody>
+          <a:bodyPr/>
+          <a:p>
+            <a:r>
+              <a:t>Footer</a:t>
+            </a:r>
+          </a:p>
+        </p:txBody>
+      </p:sp>
+      <p:sp>
+        <p:nvSpPr>
           <p:cNvPr id="4" name="PlaceHolder 3"/>
           <p:cNvSpPr>
             <a:spLocks noGrp="1"/>
           </p:cNvSpPr>
           <p:nvPr>
-            <p:ph type="ftr" idx="8"/>
+            <p:ph type="sldNum" idx="12"/>
           </p:nvPr>
         </p:nvSpPr>
         <p:spPr/>
         <p:txBody>
           <a:bodyPr/>
           <a:p>
-            <a:r>
-              <a:t>Footer</a:t>
-            </a:r>
-          </a:p>
-        </p:txBody>
-      </p:sp>
-      <p:sp>
-        <p:nvSpPr>
-          <p:cNvPr id="5" name="PlaceHolder 4"/>
-          <p:cNvSpPr>
-            <a:spLocks noGrp="1"/>
-          </p:cNvSpPr>
-          <p:nvPr>
-            <p:ph type="sldNum" idx="9"/>
-          </p:nvPr>
-        </p:nvSpPr>
-        <p:spPr/>
-        <p:txBody>
-          <a:bodyPr/>
-          <a:p>
-            <a:fld id="{F4925D94-2F82-4545-BC38-4D55209AFA7C}" type="slidenum">
+            <a:fld id="{3F6FF1C1-72B9-4B20-A2AF-ABBB2E0A44D5}" type="slidenum">
               <a:t>&lt;#&gt;</a:t>
             </a:fld>
           </a:p>
@@ -1197,12 +2279,12 @@
       </p:sp>
       <p:sp>
         <p:nvSpPr>
-          <p:cNvPr id="6" name="PlaceHolder 5"/>
-          <p:cNvSpPr>
-            <a:spLocks noGrp="1"/>
-          </p:cNvSpPr>
-          <p:nvPr>
-            <p:ph type="dt" idx="7"/>
+          <p:cNvPr id="5" name="PlaceHolder 4"/>
+          <p:cNvSpPr>
+            <a:spLocks noGrp="1"/>
+          </p:cNvSpPr>
+          <p:nvPr>
+            <p:ph type="dt" idx="10"/>
           </p:nvPr>
         </p:nvSpPr>
         <p:spPr/>
@@ -1221,7 +2303,7 @@
 </p:sldLayout>
 </file>
 
-<file path=ppt/slideLayouts/slideLayout5.xml><?xml version="1.0" encoding="utf-8"?>
+<file path=ppt/slideLayouts/slideLayout6.xml><?xml version="1.0" encoding="utf-8"?>
 <p:sldLayout xmlns:a="http://schemas.openxmlformats.org/drawingml/2006/main" xmlns:p="http://schemas.openxmlformats.org/presentationml/2006/main" xmlns:r="http://schemas.openxmlformats.org/officeDocument/2006/relationships" xmlns:p14="http://schemas.microsoft.com/office/powerpoint/2010/main" xmlns:p15="http://schemas.microsoft.com/office/powerpoint/2012/main" xmlns:mc="http://schemas.openxmlformats.org/markup-compatibility/2006" type="obj" preserve="1">
   <p:cSld name="Title and Content">
     <p:spTree>
@@ -1240,7 +2322,7 @@
       </p:grpSpPr>
       <p:sp>
         <p:nvSpPr>
-          <p:cNvPr id="28" name="PlaceHolder 1"/>
+          <p:cNvPr id="26" name="PlaceHolder 1"/>
           <p:cNvSpPr>
             <a:spLocks noGrp="1"/>
           </p:cNvSpPr>
@@ -1250,8 +2332,8 @@
         </p:nvSpPr>
         <p:spPr>
           <a:xfrm>
-            <a:off x="457200" y="273600"/>
-            <a:ext cx="8229240" cy="1144800"/>
+            <a:off x="457200" y="274680"/>
+            <a:ext cx="8229240" cy="1142640"/>
           </a:xfrm>
           <a:prstGeom prst="rect">
             <a:avLst/>
@@ -1280,7 +2362,7 @@
       </p:sp>
       <p:sp>
         <p:nvSpPr>
-          <p:cNvPr id="29" name="PlaceHolder 2"/>
+          <p:cNvPr id="27" name="PlaceHolder 2"/>
           <p:cNvSpPr>
             <a:spLocks noGrp="1"/>
           </p:cNvSpPr>
@@ -1355,7 +2437,7 @@
         <p:txBody>
           <a:bodyPr/>
           <a:p>
-            <a:fld id="{340678B5-9647-4225-A42B-5417A629F475}" type="slidenum">
+            <a:fld id="{F61CA1B0-D6A9-4BC4-975F-8920D8B0FAA8}" type="slidenum">
               <a:t>&lt;#&gt;</a:t>
             </a:fld>
           </a:p>
@@ -1387,9 +2469,9 @@
 </p:sldLayout>
 </file>
 
-<file path=ppt/slideLayouts/slideLayout6.xml><?xml version="1.0" encoding="utf-8"?>
-<p:sldLayout xmlns:a="http://schemas.openxmlformats.org/drawingml/2006/main" xmlns:p="http://schemas.openxmlformats.org/presentationml/2006/main" xmlns:r="http://schemas.openxmlformats.org/officeDocument/2006/relationships" xmlns:p14="http://schemas.microsoft.com/office/powerpoint/2010/main" xmlns:p15="http://schemas.microsoft.com/office/powerpoint/2012/main" xmlns:mc="http://schemas.openxmlformats.org/markup-compatibility/2006" type="blank" preserve="1">
-  <p:cSld name="Blank">
+<file path=ppt/slideLayouts/slideLayout7.xml><?xml version="1.0" encoding="utf-8"?>
+<p:sldLayout xmlns:a="http://schemas.openxmlformats.org/drawingml/2006/main" xmlns:p="http://schemas.openxmlformats.org/presentationml/2006/main" xmlns:r="http://schemas.openxmlformats.org/officeDocument/2006/relationships" xmlns:p14="http://schemas.microsoft.com/office/powerpoint/2010/main" xmlns:p15="http://schemas.microsoft.com/office/powerpoint/2012/main" xmlns:mc="http://schemas.openxmlformats.org/markup-compatibility/2006" type="titleOnly" preserve="1">
+  <p:cSld name="Section Header">
     <p:spTree>
       <p:nvGrpSpPr>
         <p:cNvPr id="1" name=""/>
@@ -1406,12 +2488,52 @@
       </p:grpSpPr>
       <p:sp>
         <p:nvSpPr>
-          <p:cNvPr id="2" name="PlaceHolder 1"/>
-          <p:cNvSpPr>
-            <a:spLocks noGrp="1"/>
-          </p:cNvSpPr>
-          <p:nvPr>
-            <p:ph type="ftr" idx="26"/>
+          <p:cNvPr id="33" name="PlaceHolder 1"/>
+          <p:cNvSpPr>
+            <a:spLocks noGrp="1"/>
+          </p:cNvSpPr>
+          <p:nvPr>
+            <p:ph type="title"/>
+          </p:nvPr>
+        </p:nvSpPr>
+        <p:spPr>
+          <a:xfrm>
+            <a:off x="457200" y="274680"/>
+            <a:ext cx="8229240" cy="1142640"/>
+          </a:xfrm>
+          <a:prstGeom prst="rect">
+            <a:avLst/>
+          </a:prstGeom>
+          <a:noFill/>
+          <a:ln w="0">
+            <a:noFill/>
+          </a:ln>
+        </p:spPr>
+        <p:txBody>
+          <a:bodyPr lIns="0" rIns="0" tIns="0" bIns="0" anchor="ctr">
+            <a:noAutofit/>
+          </a:bodyPr>
+          <a:p>
+            <a:pPr indent="0">
+              <a:buNone/>
+            </a:pPr>
+            <a:endParaRPr b="0" lang="en-US" sz="1800" spc="-1" strike="noStrike">
+              <a:solidFill>
+                <a:schemeClr val="dk1"/>
+              </a:solidFill>
+              <a:latin typeface="Calibri"/>
+            </a:endParaRPr>
+          </a:p>
+        </p:txBody>
+      </p:sp>
+      <p:sp>
+        <p:nvSpPr>
+          <p:cNvPr id="3" name="PlaceHolder 2"/>
+          <p:cNvSpPr>
+            <a:spLocks noGrp="1"/>
+          </p:cNvSpPr>
+          <p:nvPr>
+            <p:ph type="ftr" idx="14"/>
           </p:nvPr>
         </p:nvSpPr>
         <p:spPr/>
@@ -1426,19 +2548,19 @@
       </p:sp>
       <p:sp>
         <p:nvSpPr>
-          <p:cNvPr id="3" name="PlaceHolder 2"/>
-          <p:cNvSpPr>
-            <a:spLocks noGrp="1"/>
-          </p:cNvSpPr>
-          <p:nvPr>
-            <p:ph type="sldNum" idx="27"/>
+          <p:cNvPr id="4" name="PlaceHolder 3"/>
+          <p:cNvSpPr>
+            <a:spLocks noGrp="1"/>
+          </p:cNvSpPr>
+          <p:nvPr>
+            <p:ph type="sldNum" idx="15"/>
           </p:nvPr>
         </p:nvSpPr>
         <p:spPr/>
         <p:txBody>
           <a:bodyPr/>
           <a:p>
-            <a:fld id="{FD5A7105-C50C-4847-8045-89D2D9142E51}" type="slidenum">
+            <a:fld id="{4A4AE059-867A-4910-AF0D-758659533CFC}" type="slidenum">
               <a:t>&lt;#&gt;</a:t>
             </a:fld>
           </a:p>
@@ -1446,12 +2568,258 @@
       </p:sp>
       <p:sp>
         <p:nvSpPr>
+          <p:cNvPr id="5" name="PlaceHolder 4"/>
+          <p:cNvSpPr>
+            <a:spLocks noGrp="1"/>
+          </p:cNvSpPr>
+          <p:nvPr>
+            <p:ph type="dt" idx="13"/>
+          </p:nvPr>
+        </p:nvSpPr>
+        <p:spPr/>
+        <p:txBody>
+          <a:bodyPr/>
+          <a:p>
+            <a:r>
+              <a:rPr lang="en-US"/>
+              <a:t/>
+            </a:r>
+          </a:p>
+        </p:txBody>
+      </p:sp>
+    </p:spTree>
+  </p:cSld>
+</p:sldLayout>
+</file>
+
+<file path=ppt/slideLayouts/slideLayout8.xml><?xml version="1.0" encoding="utf-8"?>
+<p:sldLayout xmlns:a="http://schemas.openxmlformats.org/drawingml/2006/main" xmlns:p="http://schemas.openxmlformats.org/presentationml/2006/main" xmlns:r="http://schemas.openxmlformats.org/officeDocument/2006/relationships" xmlns:p14="http://schemas.microsoft.com/office/powerpoint/2010/main" xmlns:p15="http://schemas.microsoft.com/office/powerpoint/2012/main" xmlns:mc="http://schemas.openxmlformats.org/markup-compatibility/2006" type="titleOnly" preserve="1">
+  <p:cSld name="Two Content">
+    <p:spTree>
+      <p:nvGrpSpPr>
+        <p:cNvPr id="1" name=""/>
+        <p:cNvGrpSpPr/>
+        <p:nvPr/>
+      </p:nvGrpSpPr>
+      <p:grpSpPr>
+        <a:xfrm>
+          <a:off x="0" y="0"/>
+          <a:ext cx="0" cy="0"/>
+          <a:chOff x="0" y="0"/>
+          <a:chExt cx="0" cy="0"/>
+        </a:xfrm>
+      </p:grpSpPr>
+      <p:sp>
+        <p:nvSpPr>
+          <p:cNvPr id="40" name="PlaceHolder 1"/>
+          <p:cNvSpPr>
+            <a:spLocks noGrp="1"/>
+          </p:cNvSpPr>
+          <p:nvPr>
+            <p:ph type="title"/>
+          </p:nvPr>
+        </p:nvSpPr>
+        <p:spPr>
+          <a:xfrm>
+            <a:off x="457200" y="274680"/>
+            <a:ext cx="8229240" cy="1142640"/>
+          </a:xfrm>
+          <a:prstGeom prst="rect">
+            <a:avLst/>
+          </a:prstGeom>
+          <a:noFill/>
+          <a:ln w="0">
+            <a:noFill/>
+          </a:ln>
+        </p:spPr>
+        <p:txBody>
+          <a:bodyPr lIns="0" rIns="0" tIns="0" bIns="0" anchor="ctr">
+            <a:noAutofit/>
+          </a:bodyPr>
+          <a:p>
+            <a:pPr indent="0">
+              <a:buNone/>
+            </a:pPr>
+            <a:endParaRPr b="0" lang="en-US" sz="1800" spc="-1" strike="noStrike">
+              <a:solidFill>
+                <a:schemeClr val="dk1"/>
+              </a:solidFill>
+              <a:latin typeface="Calibri"/>
+            </a:endParaRPr>
+          </a:p>
+        </p:txBody>
+      </p:sp>
+      <p:sp>
+        <p:nvSpPr>
+          <p:cNvPr id="3" name="PlaceHolder 2"/>
+          <p:cNvSpPr>
+            <a:spLocks noGrp="1"/>
+          </p:cNvSpPr>
+          <p:nvPr>
+            <p:ph type="ftr" idx="17"/>
+          </p:nvPr>
+        </p:nvSpPr>
+        <p:spPr/>
+        <p:txBody>
+          <a:bodyPr/>
+          <a:p>
+            <a:r>
+              <a:t>Footer</a:t>
+            </a:r>
+          </a:p>
+        </p:txBody>
+      </p:sp>
+      <p:sp>
+        <p:nvSpPr>
           <p:cNvPr id="4" name="PlaceHolder 3"/>
           <p:cNvSpPr>
             <a:spLocks noGrp="1"/>
           </p:cNvSpPr>
           <p:nvPr>
-            <p:ph type="dt" idx="25"/>
+            <p:ph type="sldNum" idx="18"/>
+          </p:nvPr>
+        </p:nvSpPr>
+        <p:spPr/>
+        <p:txBody>
+          <a:bodyPr/>
+          <a:p>
+            <a:fld id="{57D789A9-666D-4E3E-BFA1-8D29C216374F}" type="slidenum">
+              <a:t>&lt;#&gt;</a:t>
+            </a:fld>
+          </a:p>
+        </p:txBody>
+      </p:sp>
+      <p:sp>
+        <p:nvSpPr>
+          <p:cNvPr id="5" name="PlaceHolder 4"/>
+          <p:cNvSpPr>
+            <a:spLocks noGrp="1"/>
+          </p:cNvSpPr>
+          <p:nvPr>
+            <p:ph type="dt" idx="16"/>
+          </p:nvPr>
+        </p:nvSpPr>
+        <p:spPr/>
+        <p:txBody>
+          <a:bodyPr/>
+          <a:p>
+            <a:r>
+              <a:rPr lang="en-US"/>
+              <a:t/>
+            </a:r>
+          </a:p>
+        </p:txBody>
+      </p:sp>
+    </p:spTree>
+  </p:cSld>
+</p:sldLayout>
+</file>
+
+<file path=ppt/slideLayouts/slideLayout9.xml><?xml version="1.0" encoding="utf-8"?>
+<p:sldLayout xmlns:a="http://schemas.openxmlformats.org/drawingml/2006/main" xmlns:p="http://schemas.openxmlformats.org/presentationml/2006/main" xmlns:r="http://schemas.openxmlformats.org/officeDocument/2006/relationships" xmlns:p14="http://schemas.microsoft.com/office/powerpoint/2010/main" xmlns:p15="http://schemas.microsoft.com/office/powerpoint/2012/main" xmlns:mc="http://schemas.openxmlformats.org/markup-compatibility/2006" type="titleOnly" preserve="1">
+  <p:cSld name="Comparison">
+    <p:spTree>
+      <p:nvGrpSpPr>
+        <p:cNvPr id="1" name=""/>
+        <p:cNvGrpSpPr/>
+        <p:nvPr/>
+      </p:nvGrpSpPr>
+      <p:grpSpPr>
+        <a:xfrm>
+          <a:off x="0" y="0"/>
+          <a:ext cx="0" cy="0"/>
+          <a:chOff x="0" y="0"/>
+          <a:chExt cx="0" cy="0"/>
+        </a:xfrm>
+      </p:grpSpPr>
+      <p:sp>
+        <p:nvSpPr>
+          <p:cNvPr id="49" name="PlaceHolder 1"/>
+          <p:cNvSpPr>
+            <a:spLocks noGrp="1"/>
+          </p:cNvSpPr>
+          <p:nvPr>
+            <p:ph type="title"/>
+          </p:nvPr>
+        </p:nvSpPr>
+        <p:spPr>
+          <a:xfrm>
+            <a:off x="457200" y="274680"/>
+            <a:ext cx="8229240" cy="1142640"/>
+          </a:xfrm>
+          <a:prstGeom prst="rect">
+            <a:avLst/>
+          </a:prstGeom>
+          <a:noFill/>
+          <a:ln w="0">
+            <a:noFill/>
+          </a:ln>
+        </p:spPr>
+        <p:txBody>
+          <a:bodyPr lIns="0" rIns="0" tIns="0" bIns="0" anchor="ctr">
+            <a:noAutofit/>
+          </a:bodyPr>
+          <a:p>
+            <a:pPr indent="0">
+              <a:buNone/>
+            </a:pPr>
+            <a:endParaRPr b="0" lang="en-US" sz="1800" spc="-1" strike="noStrike">
+              <a:solidFill>
+                <a:schemeClr val="dk1"/>
+              </a:solidFill>
+              <a:latin typeface="Calibri"/>
+            </a:endParaRPr>
+          </a:p>
+        </p:txBody>
+      </p:sp>
+      <p:sp>
+        <p:nvSpPr>
+          <p:cNvPr id="3" name="PlaceHolder 2"/>
+          <p:cNvSpPr>
+            <a:spLocks noGrp="1"/>
+          </p:cNvSpPr>
+          <p:nvPr>
+            <p:ph type="ftr" idx="20"/>
+          </p:nvPr>
+        </p:nvSpPr>
+        <p:spPr/>
+        <p:txBody>
+          <a:bodyPr/>
+          <a:p>
+            <a:r>
+              <a:t>Footer</a:t>
+            </a:r>
+          </a:p>
+        </p:txBody>
+      </p:sp>
+      <p:sp>
+        <p:nvSpPr>
+          <p:cNvPr id="4" name="PlaceHolder 3"/>
+          <p:cNvSpPr>
+            <a:spLocks noGrp="1"/>
+          </p:cNvSpPr>
+          <p:nvPr>
+            <p:ph type="sldNum" idx="21"/>
+          </p:nvPr>
+        </p:nvSpPr>
+        <p:spPr/>
+        <p:txBody>
+          <a:bodyPr/>
+          <a:p>
+            <a:fld id="{3787AB18-F177-4092-B74F-20EAA67870ED}" type="slidenum">
+              <a:t>&lt;#&gt;</a:t>
+            </a:fld>
+          </a:p>
+        </p:txBody>
+      </p:sp>
+      <p:sp>
+        <p:nvSpPr>
+          <p:cNvPr id="5" name="PlaceHolder 4"/>
+          <p:cNvSpPr>
+            <a:spLocks noGrp="1"/>
+          </p:cNvSpPr>
+          <p:nvPr>
+            <p:ph type="dt" idx="19"/>
           </p:nvPr>
         </p:nvSpPr>
         <p:spPr/>
@@ -1726,7 +3094,7 @@
               </a:lnSpc>
               <a:buNone/>
             </a:pPr>
-            <a:fld id="{472090B9-A476-4B79-98B4-1E844A289FC6}" type="slidenum">
+            <a:fld id="{8950E2FD-CEC5-4FF4-85BD-A5796420F8DC}" type="slidenum">
               <a:rPr b="0" lang="en-US" sz="1200" spc="-1" strike="noStrike">
                 <a:solidFill>
                   <a:schemeClr val="dk1">
@@ -2007,7 +3375,7 @@
       </p:grpSpPr>
       <p:sp>
         <p:nvSpPr>
-          <p:cNvPr id="58" name="PlaceHolder 1"/>
+          <p:cNvPr id="61" name="PlaceHolder 1"/>
           <p:cNvSpPr>
             <a:spLocks noGrp="1"/>
           </p:cNvSpPr>
@@ -2059,7 +3427,7 @@
       </p:sp>
       <p:sp>
         <p:nvSpPr>
-          <p:cNvPr id="59" name="PlaceHolder 2"/>
+          <p:cNvPr id="62" name="PlaceHolder 2"/>
           <p:cNvSpPr>
             <a:spLocks noGrp="1"/>
           </p:cNvSpPr>
@@ -2243,7 +3611,7 @@
       </p:sp>
       <p:sp>
         <p:nvSpPr>
-          <p:cNvPr id="60" name="PlaceHolder 3"/>
+          <p:cNvPr id="63" name="PlaceHolder 3"/>
           <p:cNvSpPr>
             <a:spLocks noGrp="1"/>
           </p:cNvSpPr>
@@ -2301,7 +3669,7 @@
       </p:sp>
       <p:sp>
         <p:nvSpPr>
-          <p:cNvPr id="61" name="PlaceHolder 4"/>
+          <p:cNvPr id="64" name="PlaceHolder 4"/>
           <p:cNvSpPr>
             <a:spLocks noGrp="1"/>
           </p:cNvSpPr>
@@ -2371,7 +3739,7 @@
       </p:sp>
       <p:sp>
         <p:nvSpPr>
-          <p:cNvPr id="62" name="PlaceHolder 5"/>
+          <p:cNvPr id="65" name="PlaceHolder 5"/>
           <p:cNvSpPr>
             <a:spLocks noGrp="1"/>
           </p:cNvSpPr>
@@ -2431,7 +3799,7 @@
       </p:sp>
       <p:sp>
         <p:nvSpPr>
-          <p:cNvPr id="63" name="PlaceHolder 6"/>
+          <p:cNvPr id="66" name="PlaceHolder 6"/>
           <p:cNvSpPr>
             <a:spLocks noGrp="1"/>
           </p:cNvSpPr>
@@ -2479,7 +3847,7 @@
               </a:lnSpc>
               <a:buNone/>
             </a:pPr>
-            <a:fld id="{320CB79E-8BD3-409E-8AA5-4CA2804D3839}" type="slidenum">
+            <a:fld id="{AD1D9FE7-D8B9-4122-930E-44B4169E09BA}" type="slidenum">
               <a:rPr b="0" lang="en-US" sz="1200" spc="-1" strike="noStrike">
                 <a:solidFill>
                   <a:schemeClr val="dk1">
@@ -2532,7 +3900,7 @@
       </p:grpSpPr>
       <p:sp>
         <p:nvSpPr>
-          <p:cNvPr id="64" name="PlaceHolder 1"/>
+          <p:cNvPr id="67" name="PlaceHolder 1"/>
           <p:cNvSpPr>
             <a:spLocks noGrp="1"/>
           </p:cNvSpPr>
@@ -2584,7 +3952,7 @@
       </p:sp>
       <p:sp>
         <p:nvSpPr>
-          <p:cNvPr id="65" name="PlaceHolder 2"/>
+          <p:cNvPr id="68" name="PlaceHolder 2"/>
           <p:cNvSpPr>
             <a:spLocks noGrp="1"/>
           </p:cNvSpPr>
@@ -2809,7 +4177,7 @@
       </p:sp>
       <p:sp>
         <p:nvSpPr>
-          <p:cNvPr id="66" name="PlaceHolder 3"/>
+          <p:cNvPr id="69" name="PlaceHolder 3"/>
           <p:cNvSpPr>
             <a:spLocks noGrp="1"/>
           </p:cNvSpPr>
@@ -2867,7 +4235,7 @@
       </p:sp>
       <p:sp>
         <p:nvSpPr>
-          <p:cNvPr id="67" name="PlaceHolder 4"/>
+          <p:cNvPr id="70" name="PlaceHolder 4"/>
           <p:cNvSpPr>
             <a:spLocks noGrp="1"/>
           </p:cNvSpPr>
@@ -2937,7 +4305,7 @@
       </p:sp>
       <p:sp>
         <p:nvSpPr>
-          <p:cNvPr id="68" name="PlaceHolder 5"/>
+          <p:cNvPr id="71" name="PlaceHolder 5"/>
           <p:cNvSpPr>
             <a:spLocks noGrp="1"/>
           </p:cNvSpPr>
@@ -2997,7 +4365,7 @@
       </p:sp>
       <p:sp>
         <p:nvSpPr>
-          <p:cNvPr id="69" name="PlaceHolder 6"/>
+          <p:cNvPr id="72" name="PlaceHolder 6"/>
           <p:cNvSpPr>
             <a:spLocks noGrp="1"/>
           </p:cNvSpPr>
@@ -3045,7 +4413,7 @@
               </a:lnSpc>
               <a:buNone/>
             </a:pPr>
-            <a:fld id="{E738F866-E515-4F2D-83D3-F880A801C74D}" type="slidenum">
+            <a:fld id="{D3EC5C55-2CDA-4527-A148-219BE336971B}" type="slidenum">
               <a:rPr b="0" lang="en-US" sz="1200" spc="-1" strike="noStrike">
                 <a:solidFill>
                   <a:schemeClr val="dk1">
@@ -3098,7 +4466,7 @@
       </p:grpSpPr>
       <p:sp>
         <p:nvSpPr>
-          <p:cNvPr id="9" name="PlaceHolder 1"/>
+          <p:cNvPr id="8" name="PlaceHolder 1"/>
           <p:cNvSpPr>
             <a:spLocks noGrp="1"/>
           </p:cNvSpPr>
@@ -3150,7 +4518,7 @@
       </p:sp>
       <p:sp>
         <p:nvSpPr>
-          <p:cNvPr id="10" name="PlaceHolder 2"/>
+          <p:cNvPr id="9" name="PlaceHolder 2"/>
           <p:cNvSpPr>
             <a:spLocks noGrp="1"/>
           </p:cNvSpPr>
@@ -3334,7 +4702,7 @@
       </p:sp>
       <p:sp>
         <p:nvSpPr>
-          <p:cNvPr id="11" name="PlaceHolder 3"/>
+          <p:cNvPr id="10" name="PlaceHolder 3"/>
           <p:cNvSpPr>
             <a:spLocks noGrp="1"/>
           </p:cNvSpPr>
@@ -3404,7 +4772,7 @@
       </p:sp>
       <p:sp>
         <p:nvSpPr>
-          <p:cNvPr id="12" name="PlaceHolder 4"/>
+          <p:cNvPr id="11" name="PlaceHolder 4"/>
           <p:cNvSpPr>
             <a:spLocks noGrp="1"/>
           </p:cNvSpPr>
@@ -3464,7 +4832,7 @@
       </p:sp>
       <p:sp>
         <p:nvSpPr>
-          <p:cNvPr id="13" name="PlaceHolder 5"/>
+          <p:cNvPr id="12" name="PlaceHolder 5"/>
           <p:cNvSpPr>
             <a:spLocks noGrp="1"/>
           </p:cNvSpPr>
@@ -3512,7 +4880,7 @@
               </a:lnSpc>
               <a:buNone/>
             </a:pPr>
-            <a:fld id="{CD466E23-4399-4643-AB8C-78B480103649}" type="slidenum">
+            <a:fld id="{E946EDCC-CDD8-4770-ACF6-D08B48FD0FAB}" type="slidenum">
               <a:rPr b="0" lang="en-US" sz="1200" spc="-1" strike="noStrike">
                 <a:solidFill>
                   <a:schemeClr val="dk1">
@@ -3567,7 +4935,7 @@
       </p:grpSpPr>
       <p:sp>
         <p:nvSpPr>
-          <p:cNvPr id="16" name="PlaceHolder 1"/>
+          <p:cNvPr id="14" name="PlaceHolder 1"/>
           <p:cNvSpPr>
             <a:spLocks noGrp="1"/>
           </p:cNvSpPr>
@@ -3619,7 +4987,7 @@
       </p:sp>
       <p:sp>
         <p:nvSpPr>
-          <p:cNvPr id="17" name="PlaceHolder 2"/>
+          <p:cNvPr id="15" name="PlaceHolder 2"/>
           <p:cNvSpPr>
             <a:spLocks noGrp="1"/>
           </p:cNvSpPr>
@@ -3803,7 +5171,7 @@
       </p:sp>
       <p:sp>
         <p:nvSpPr>
-          <p:cNvPr id="18" name="PlaceHolder 3"/>
+          <p:cNvPr id="16" name="PlaceHolder 3"/>
           <p:cNvSpPr>
             <a:spLocks noGrp="1"/>
           </p:cNvSpPr>
@@ -3873,7 +5241,7 @@
       </p:sp>
       <p:sp>
         <p:nvSpPr>
-          <p:cNvPr id="19" name="PlaceHolder 4"/>
+          <p:cNvPr id="17" name="PlaceHolder 4"/>
           <p:cNvSpPr>
             <a:spLocks noGrp="1"/>
           </p:cNvSpPr>
@@ -3933,7 +5301,7 @@
       </p:sp>
       <p:sp>
         <p:nvSpPr>
-          <p:cNvPr id="20" name="PlaceHolder 5"/>
+          <p:cNvPr id="18" name="PlaceHolder 5"/>
           <p:cNvSpPr>
             <a:spLocks noGrp="1"/>
           </p:cNvSpPr>
@@ -3981,7 +5349,7 @@
               </a:lnSpc>
               <a:buNone/>
             </a:pPr>
-            <a:fld id="{899B51F5-58E9-4ED7-AFA0-DDEE8F51A079}" type="slidenum">
+            <a:fld id="{D97498CF-AFD0-4935-A8C7-5F55854B979A}" type="slidenum">
               <a:rPr b="0" lang="en-US" sz="1200" spc="-1" strike="noStrike">
                 <a:solidFill>
                   <a:schemeClr val="dk1">
@@ -4036,7 +5404,7 @@
       </p:grpSpPr>
       <p:sp>
         <p:nvSpPr>
-          <p:cNvPr id="23" name="PlaceHolder 1"/>
+          <p:cNvPr id="20" name="PlaceHolder 1"/>
           <p:cNvSpPr>
             <a:spLocks noGrp="1"/>
           </p:cNvSpPr>
@@ -4088,7 +5456,7 @@
       </p:sp>
       <p:sp>
         <p:nvSpPr>
-          <p:cNvPr id="24" name="PlaceHolder 2"/>
+          <p:cNvPr id="21" name="PlaceHolder 2"/>
           <p:cNvSpPr>
             <a:spLocks noGrp="1"/>
           </p:cNvSpPr>
@@ -4272,7 +5640,7 @@
       </p:sp>
       <p:sp>
         <p:nvSpPr>
-          <p:cNvPr id="25" name="PlaceHolder 3"/>
+          <p:cNvPr id="22" name="PlaceHolder 3"/>
           <p:cNvSpPr>
             <a:spLocks noGrp="1"/>
           </p:cNvSpPr>
@@ -4342,7 +5710,7 @@
       </p:sp>
       <p:sp>
         <p:nvSpPr>
-          <p:cNvPr id="26" name="PlaceHolder 4"/>
+          <p:cNvPr id="23" name="PlaceHolder 4"/>
           <p:cNvSpPr>
             <a:spLocks noGrp="1"/>
           </p:cNvSpPr>
@@ -4402,7 +5770,7 @@
       </p:sp>
       <p:sp>
         <p:nvSpPr>
-          <p:cNvPr id="27" name="PlaceHolder 5"/>
+          <p:cNvPr id="24" name="PlaceHolder 5"/>
           <p:cNvSpPr>
             <a:spLocks noGrp="1"/>
           </p:cNvSpPr>
@@ -4450,7 +5818,7 @@
               </a:lnSpc>
               <a:buNone/>
             </a:pPr>
-            <a:fld id="{B2020FA9-7DCD-4CF7-9215-BB605CA475B5}" type="slidenum">
+            <a:fld id="{DC9F6FA3-ADF3-4CE5-978F-D1331A3228DA}" type="slidenum">
               <a:rPr b="0" lang="en-US" sz="1200" spc="-1" strike="noStrike">
                 <a:solidFill>
                   <a:schemeClr val="dk1">
@@ -4475,6 +5843,7 @@
   <p:clrMap bg1="lt1" bg2="lt2" tx1="dk1" tx2="dk2" accent1="accent1" accent2="accent2" accent3="accent3" accent4="accent4" accent5="accent5" accent6="accent6" hlink="hlink" folHlink="folHlink"/>
   <p:sldLayoutIdLst>
     <p:sldLayoutId id="2147483656" r:id="rId2"/>
+    <p:sldLayoutId id="2147483657" r:id="rId3"/>
   </p:sldLayoutIdLst>
 </p:sldMaster>
 </file>
@@ -4505,7 +5874,7 @@
       </p:grpSpPr>
       <p:sp>
         <p:nvSpPr>
-          <p:cNvPr id="30" name="PlaceHolder 1"/>
+          <p:cNvPr id="28" name="PlaceHolder 1"/>
           <p:cNvSpPr>
             <a:spLocks noGrp="1"/>
           </p:cNvSpPr>
@@ -4557,7 +5926,7 @@
       </p:sp>
       <p:sp>
         <p:nvSpPr>
-          <p:cNvPr id="31" name="PlaceHolder 2"/>
+          <p:cNvPr id="29" name="PlaceHolder 2"/>
           <p:cNvSpPr>
             <a:spLocks noGrp="1"/>
           </p:cNvSpPr>
@@ -4622,7 +5991,7 @@
       </p:sp>
       <p:sp>
         <p:nvSpPr>
-          <p:cNvPr id="32" name="PlaceHolder 3"/>
+          <p:cNvPr id="30" name="PlaceHolder 3"/>
           <p:cNvSpPr>
             <a:spLocks noGrp="1"/>
           </p:cNvSpPr>
@@ -4692,7 +6061,7 @@
       </p:sp>
       <p:sp>
         <p:nvSpPr>
-          <p:cNvPr id="33" name="PlaceHolder 4"/>
+          <p:cNvPr id="31" name="PlaceHolder 4"/>
           <p:cNvSpPr>
             <a:spLocks noGrp="1"/>
           </p:cNvSpPr>
@@ -4752,7 +6121,7 @@
       </p:sp>
       <p:sp>
         <p:nvSpPr>
-          <p:cNvPr id="34" name="PlaceHolder 5"/>
+          <p:cNvPr id="32" name="PlaceHolder 5"/>
           <p:cNvSpPr>
             <a:spLocks noGrp="1"/>
           </p:cNvSpPr>
@@ -4800,7 +6169,7 @@
               </a:lnSpc>
               <a:buNone/>
             </a:pPr>
-            <a:fld id="{569779DE-2524-4C4C-B2DB-F9DE2B5790E0}" type="slidenum">
+            <a:fld id="{7041A9F4-2C44-467C-9EF7-DFDFE64C220E}" type="slidenum">
               <a:rPr b="0" lang="en-US" sz="1200" spc="-1" strike="noStrike">
                 <a:solidFill>
                   <a:schemeClr val="dk1">
@@ -4823,7 +6192,9 @@
     </p:spTree>
   </p:cSld>
   <p:clrMap bg1="lt1" bg2="lt2" tx1="dk1" tx2="dk2" accent1="accent1" accent2="accent2" accent3="accent3" accent4="accent4" accent5="accent5" accent6="accent6" hlink="hlink" folHlink="folHlink"/>
-  <p:sldLayoutIdLst/>
+  <p:sldLayoutIdLst>
+    <p:sldLayoutId id="2147483659" r:id="rId2"/>
+  </p:sldLayoutIdLst>
 </p:sldMaster>
 </file>
 
@@ -4853,7 +6224,7 @@
       </p:grpSpPr>
       <p:sp>
         <p:nvSpPr>
-          <p:cNvPr id="35" name="PlaceHolder 1"/>
+          <p:cNvPr id="34" name="PlaceHolder 1"/>
           <p:cNvSpPr>
             <a:spLocks noGrp="1"/>
           </p:cNvSpPr>
@@ -4905,7 +6276,7 @@
       </p:sp>
       <p:sp>
         <p:nvSpPr>
-          <p:cNvPr id="36" name="PlaceHolder 2"/>
+          <p:cNvPr id="35" name="PlaceHolder 2"/>
           <p:cNvSpPr>
             <a:spLocks noGrp="1"/>
           </p:cNvSpPr>
@@ -5089,7 +6460,7 @@
       </p:sp>
       <p:sp>
         <p:nvSpPr>
-          <p:cNvPr id="37" name="PlaceHolder 3"/>
+          <p:cNvPr id="36" name="PlaceHolder 3"/>
           <p:cNvSpPr>
             <a:spLocks noGrp="1"/>
           </p:cNvSpPr>
@@ -5268,7 +6639,7 @@
       </p:sp>
       <p:sp>
         <p:nvSpPr>
-          <p:cNvPr id="38" name="PlaceHolder 4"/>
+          <p:cNvPr id="37" name="PlaceHolder 4"/>
           <p:cNvSpPr>
             <a:spLocks noGrp="1"/>
           </p:cNvSpPr>
@@ -5338,7 +6709,7 @@
       </p:sp>
       <p:sp>
         <p:nvSpPr>
-          <p:cNvPr id="39" name="PlaceHolder 5"/>
+          <p:cNvPr id="38" name="PlaceHolder 5"/>
           <p:cNvSpPr>
             <a:spLocks noGrp="1"/>
           </p:cNvSpPr>
@@ -5398,7 +6769,7 @@
       </p:sp>
       <p:sp>
         <p:nvSpPr>
-          <p:cNvPr id="40" name="PlaceHolder 6"/>
+          <p:cNvPr id="39" name="PlaceHolder 6"/>
           <p:cNvSpPr>
             <a:spLocks noGrp="1"/>
           </p:cNvSpPr>
@@ -5446,7 +6817,7 @@
               </a:lnSpc>
               <a:buNone/>
             </a:pPr>
-            <a:fld id="{7DF2A7D9-9EBE-495C-AB8D-7C12B3CD99AA}" type="slidenum">
+            <a:fld id="{C3630059-ADE9-4ABC-89A2-B224310FF7D6}" type="slidenum">
               <a:rPr b="0" lang="en-US" sz="1200" spc="-1" strike="noStrike">
                 <a:solidFill>
                   <a:schemeClr val="dk1">
@@ -5469,7 +6840,9 @@
     </p:spTree>
   </p:cSld>
   <p:clrMap bg1="lt1" bg2="lt2" tx1="dk1" tx2="dk2" accent1="accent1" accent2="accent2" accent3="accent3" accent4="accent4" accent5="accent5" accent6="accent6" hlink="hlink" folHlink="folHlink"/>
-  <p:sldLayoutIdLst/>
+  <p:sldLayoutIdLst>
+    <p:sldLayoutId id="2147483661" r:id="rId2"/>
+  </p:sldLayoutIdLst>
 </p:sldMaster>
 </file>
 
@@ -6208,7 +7581,7 @@
               </a:lnSpc>
               <a:buNone/>
             </a:pPr>
-            <a:fld id="{0AEFD9A1-BCB1-4A83-AF00-7EB01E893339}" type="slidenum">
+            <a:fld id="{3CECB59F-09FF-4849-BDED-49CEA4DA41E1}" type="slidenum">
               <a:rPr b="0" lang="en-US" sz="1200" spc="-1" strike="noStrike">
                 <a:solidFill>
                   <a:schemeClr val="dk1">
@@ -6231,7 +7604,9 @@
     </p:spTree>
   </p:cSld>
   <p:clrMap bg1="lt1" bg2="lt2" tx1="dk1" tx2="dk2" accent1="accent1" accent2="accent2" accent3="accent3" accent4="accent4" accent5="accent5" accent6="accent6" hlink="hlink" folHlink="folHlink"/>
-  <p:sldLayoutIdLst/>
+  <p:sldLayoutIdLst>
+    <p:sldLayoutId id="2147483663" r:id="rId2"/>
+  </p:sldLayoutIdLst>
 </p:sldMaster>
 </file>
 
@@ -6261,7 +7636,7 @@
       </p:grpSpPr>
       <p:sp>
         <p:nvSpPr>
-          <p:cNvPr id="49" name="PlaceHolder 1"/>
+          <p:cNvPr id="50" name="PlaceHolder 1"/>
           <p:cNvSpPr>
             <a:spLocks noGrp="1"/>
           </p:cNvSpPr>
@@ -6313,7 +7688,7 @@
       </p:sp>
       <p:sp>
         <p:nvSpPr>
-          <p:cNvPr id="50" name="PlaceHolder 2"/>
+          <p:cNvPr id="51" name="PlaceHolder 2"/>
           <p:cNvSpPr>
             <a:spLocks noGrp="1"/>
           </p:cNvSpPr>
@@ -6383,7 +7758,7 @@
       </p:sp>
       <p:sp>
         <p:nvSpPr>
-          <p:cNvPr id="51" name="PlaceHolder 3"/>
+          <p:cNvPr id="52" name="PlaceHolder 3"/>
           <p:cNvSpPr>
             <a:spLocks noGrp="1"/>
           </p:cNvSpPr>
@@ -6443,7 +7818,7 @@
       </p:sp>
       <p:sp>
         <p:nvSpPr>
-          <p:cNvPr id="52" name="PlaceHolder 4"/>
+          <p:cNvPr id="53" name="PlaceHolder 4"/>
           <p:cNvSpPr>
             <a:spLocks noGrp="1"/>
           </p:cNvSpPr>
@@ -6491,7 +7866,7 @@
               </a:lnSpc>
               <a:buNone/>
             </a:pPr>
-            <a:fld id="{A6F8F234-3D81-4E03-9C32-AC9CE06CC014}" type="slidenum">
+            <a:fld id="{D920838F-B1C1-4846-98A4-BB2EE707649D}" type="slidenum">
               <a:rPr b="0" lang="en-US" sz="1200" spc="-1" strike="noStrike">
                 <a:solidFill>
                   <a:schemeClr val="dk1">
@@ -6511,10 +7886,237 @@
           </a:p>
         </p:txBody>
       </p:sp>
+      <p:sp>
+        <p:nvSpPr>
+          <p:cNvPr id="54" name="PlaceHolder 5"/>
+          <p:cNvSpPr>
+            <a:spLocks noGrp="1"/>
+          </p:cNvSpPr>
+          <p:nvPr>
+            <p:ph type="body"/>
+          </p:nvPr>
+        </p:nvSpPr>
+        <p:spPr>
+          <a:xfrm>
+            <a:off x="457200" y="1604520"/>
+            <a:ext cx="8229240" cy="3977280"/>
+          </a:xfrm>
+          <a:prstGeom prst="rect">
+            <a:avLst/>
+          </a:prstGeom>
+          <a:noFill/>
+          <a:ln w="0">
+            <a:noFill/>
+          </a:ln>
+        </p:spPr>
+        <p:txBody>
+          <a:bodyPr lIns="0" rIns="0" tIns="0" bIns="0" anchor="t">
+            <a:normAutofit/>
+          </a:bodyPr>
+          <a:p>
+            <a:pPr marL="432000" indent="-324000">
+              <a:spcBef>
+                <a:spcPts val="1417"/>
+              </a:spcBef>
+              <a:buClr>
+                <a:srgbClr val="000000"/>
+              </a:buClr>
+              <a:buSzPct val="45000"/>
+              <a:buFont typeface="Wingdings" charset="2"/>
+              <a:buChar char=""/>
+            </a:pPr>
+            <a:r>
+              <a:rPr b="0" lang="en-US" sz="3200" spc="-1" strike="noStrike">
+                <a:solidFill>
+                  <a:schemeClr val="dk1"/>
+                </a:solidFill>
+                <a:latin typeface="Calibri"/>
+              </a:rPr>
+              <a:t>Click to edit the outline text format</a:t>
+            </a:r>
+            <a:endParaRPr b="0" lang="en-US" sz="3200" spc="-1" strike="noStrike">
+              <a:solidFill>
+                <a:schemeClr val="dk1"/>
+              </a:solidFill>
+              <a:latin typeface="Calibri"/>
+            </a:endParaRPr>
+          </a:p>
+          <a:p>
+            <a:pPr lvl="1" marL="864000" indent="-324000">
+              <a:spcBef>
+                <a:spcPts val="1134"/>
+              </a:spcBef>
+              <a:buClr>
+                <a:srgbClr val="000000"/>
+              </a:buClr>
+              <a:buSzPct val="75000"/>
+              <a:buFont typeface="Symbol" charset="2"/>
+              <a:buChar char=""/>
+            </a:pPr>
+            <a:r>
+              <a:rPr b="0" lang="en-US" sz="2400" spc="-1" strike="noStrike">
+                <a:solidFill>
+                  <a:schemeClr val="dk1"/>
+                </a:solidFill>
+                <a:latin typeface="Calibri"/>
+              </a:rPr>
+              <a:t>Second Outline Level</a:t>
+            </a:r>
+            <a:endParaRPr b="0" lang="en-US" sz="2400" spc="-1" strike="noStrike">
+              <a:solidFill>
+                <a:schemeClr val="dk1"/>
+              </a:solidFill>
+              <a:latin typeface="Calibri"/>
+            </a:endParaRPr>
+          </a:p>
+          <a:p>
+            <a:pPr lvl="2" marL="1296000" indent="-288000">
+              <a:spcBef>
+                <a:spcPts val="850"/>
+              </a:spcBef>
+              <a:buClr>
+                <a:srgbClr val="000000"/>
+              </a:buClr>
+              <a:buSzPct val="45000"/>
+              <a:buFont typeface="Wingdings" charset="2"/>
+              <a:buChar char=""/>
+            </a:pPr>
+            <a:r>
+              <a:rPr b="0" lang="en-US" sz="2000" spc="-1" strike="noStrike">
+                <a:solidFill>
+                  <a:schemeClr val="dk1"/>
+                </a:solidFill>
+                <a:latin typeface="Calibri"/>
+              </a:rPr>
+              <a:t>Third Outline Level</a:t>
+            </a:r>
+            <a:endParaRPr b="0" lang="en-US" sz="2000" spc="-1" strike="noStrike">
+              <a:solidFill>
+                <a:schemeClr val="dk1"/>
+              </a:solidFill>
+              <a:latin typeface="Calibri"/>
+            </a:endParaRPr>
+          </a:p>
+          <a:p>
+            <a:pPr lvl="3" marL="1728000" indent="-216000">
+              <a:spcBef>
+                <a:spcPts val="567"/>
+              </a:spcBef>
+              <a:buClr>
+                <a:srgbClr val="000000"/>
+              </a:buClr>
+              <a:buSzPct val="75000"/>
+              <a:buFont typeface="Symbol" charset="2"/>
+              <a:buChar char=""/>
+            </a:pPr>
+            <a:r>
+              <a:rPr b="0" lang="en-US" sz="2000" spc="-1" strike="noStrike">
+                <a:solidFill>
+                  <a:schemeClr val="dk1"/>
+                </a:solidFill>
+                <a:latin typeface="Calibri"/>
+              </a:rPr>
+              <a:t>Fourth Outline Level</a:t>
+            </a:r>
+            <a:endParaRPr b="0" lang="en-US" sz="2000" spc="-1" strike="noStrike">
+              <a:solidFill>
+                <a:schemeClr val="dk1"/>
+              </a:solidFill>
+              <a:latin typeface="Calibri"/>
+            </a:endParaRPr>
+          </a:p>
+          <a:p>
+            <a:pPr lvl="4" marL="2160000" indent="-216000">
+              <a:spcBef>
+                <a:spcPts val="283"/>
+              </a:spcBef>
+              <a:buClr>
+                <a:srgbClr val="000000"/>
+              </a:buClr>
+              <a:buSzPct val="45000"/>
+              <a:buFont typeface="Wingdings" charset="2"/>
+              <a:buChar char=""/>
+            </a:pPr>
+            <a:r>
+              <a:rPr b="0" lang="en-US" sz="2000" spc="-1" strike="noStrike">
+                <a:solidFill>
+                  <a:schemeClr val="dk1"/>
+                </a:solidFill>
+                <a:latin typeface="Calibri"/>
+              </a:rPr>
+              <a:t>Fifth Outline Level</a:t>
+            </a:r>
+            <a:endParaRPr b="0" lang="en-US" sz="2000" spc="-1" strike="noStrike">
+              <a:solidFill>
+                <a:schemeClr val="dk1"/>
+              </a:solidFill>
+              <a:latin typeface="Calibri"/>
+            </a:endParaRPr>
+          </a:p>
+          <a:p>
+            <a:pPr lvl="5" marL="2592000" indent="-216000">
+              <a:spcBef>
+                <a:spcPts val="283"/>
+              </a:spcBef>
+              <a:buClr>
+                <a:srgbClr val="000000"/>
+              </a:buClr>
+              <a:buSzPct val="45000"/>
+              <a:buFont typeface="Wingdings" charset="2"/>
+              <a:buChar char=""/>
+            </a:pPr>
+            <a:r>
+              <a:rPr b="0" lang="en-US" sz="2000" spc="-1" strike="noStrike">
+                <a:solidFill>
+                  <a:schemeClr val="dk1"/>
+                </a:solidFill>
+                <a:latin typeface="Calibri"/>
+              </a:rPr>
+              <a:t>Sixth Outline Level</a:t>
+            </a:r>
+            <a:endParaRPr b="0" lang="en-US" sz="2000" spc="-1" strike="noStrike">
+              <a:solidFill>
+                <a:schemeClr val="dk1"/>
+              </a:solidFill>
+              <a:latin typeface="Calibri"/>
+            </a:endParaRPr>
+          </a:p>
+          <a:p>
+            <a:pPr lvl="6" marL="3024000" indent="-216000">
+              <a:spcBef>
+                <a:spcPts val="283"/>
+              </a:spcBef>
+              <a:buClr>
+                <a:srgbClr val="000000"/>
+              </a:buClr>
+              <a:buSzPct val="45000"/>
+              <a:buFont typeface="Wingdings" charset="2"/>
+              <a:buChar char=""/>
+            </a:pPr>
+            <a:r>
+              <a:rPr b="0" lang="en-US" sz="2000" spc="-1" strike="noStrike">
+                <a:solidFill>
+                  <a:schemeClr val="dk1"/>
+                </a:solidFill>
+                <a:latin typeface="Calibri"/>
+              </a:rPr>
+              <a:t>Seventh Outline Level</a:t>
+            </a:r>
+            <a:endParaRPr b="0" lang="en-US" sz="2000" spc="-1" strike="noStrike">
+              <a:solidFill>
+                <a:schemeClr val="dk1"/>
+              </a:solidFill>
+              <a:latin typeface="Calibri"/>
+            </a:endParaRPr>
+          </a:p>
+        </p:txBody>
+      </p:sp>
     </p:spTree>
   </p:cSld>
   <p:clrMap bg1="lt1" bg2="lt2" tx1="dk1" tx2="dk2" accent1="accent1" accent2="accent2" accent3="accent3" accent4="accent4" accent5="accent5" accent6="accent6" hlink="hlink" folHlink="folHlink"/>
-  <p:sldLayoutIdLst/>
+  <p:sldLayoutIdLst>
+    <p:sldLayoutId id="2147483665" r:id="rId2"/>
+  </p:sldLayoutIdLst>
 </p:sldMaster>
 </file>
 
@@ -6544,7 +8146,7 @@
       </p:grpSpPr>
       <p:sp>
         <p:nvSpPr>
-          <p:cNvPr id="53" name="PlaceHolder 1"/>
+          <p:cNvPr id="56" name="PlaceHolder 1"/>
           <p:cNvSpPr>
             <a:spLocks noGrp="1"/>
           </p:cNvSpPr>
@@ -6614,7 +8216,7 @@
       </p:sp>
       <p:sp>
         <p:nvSpPr>
-          <p:cNvPr id="54" name="PlaceHolder 2"/>
+          <p:cNvPr id="57" name="PlaceHolder 2"/>
           <p:cNvSpPr>
             <a:spLocks noGrp="1"/>
           </p:cNvSpPr>
@@ -6674,7 +8276,7 @@
       </p:sp>
       <p:sp>
         <p:nvSpPr>
-          <p:cNvPr id="55" name="PlaceHolder 3"/>
+          <p:cNvPr id="58" name="PlaceHolder 3"/>
           <p:cNvSpPr>
             <a:spLocks noGrp="1"/>
           </p:cNvSpPr>
@@ -6722,7 +8324,7 @@
               </a:lnSpc>
               <a:buNone/>
             </a:pPr>
-            <a:fld id="{00937EAF-CED0-4E68-AFED-F0FC94DB73C8}" type="slidenum">
+            <a:fld id="{1A7A21FB-8A5E-40A9-89FF-745426A21983}" type="slidenum">
               <a:rPr b="0" lang="en-US" sz="1200" spc="-1" strike="noStrike">
                 <a:solidFill>
                   <a:schemeClr val="dk1">
@@ -6744,7 +8346,7 @@
       </p:sp>
       <p:sp>
         <p:nvSpPr>
-          <p:cNvPr id="56" name="PlaceHolder 4"/>
+          <p:cNvPr id="59" name="PlaceHolder 4"/>
           <p:cNvSpPr>
             <a:spLocks noGrp="1"/>
           </p:cNvSpPr>
@@ -6793,7 +8395,7 @@
       </p:sp>
       <p:sp>
         <p:nvSpPr>
-          <p:cNvPr id="57" name="PlaceHolder 5"/>
+          <p:cNvPr id="60" name="PlaceHolder 5"/>
           <p:cNvSpPr>
             <a:spLocks noGrp="1"/>
           </p:cNvSpPr>
@@ -7020,7 +8622,7 @@
   </p:cSld>
   <p:clrMap bg1="lt1" bg2="lt2" tx1="dk1" tx2="dk2" accent1="accent1" accent2="accent2" accent3="accent3" accent4="accent4" accent5="accent5" accent6="accent6" hlink="hlink" folHlink="folHlink"/>
   <p:sldLayoutIdLst>
-    <p:sldLayoutId id="2147483662" r:id="rId2"/>
+    <p:sldLayoutId id="2147483667" r:id="rId2"/>
   </p:sldLayoutIdLst>
 </p:sldMaster>
 </file>
@@ -7044,7 +8646,7 @@
       </p:grpSpPr>
       <p:sp>
         <p:nvSpPr>
-          <p:cNvPr id="76" name="PlaceHolder 1"/>
+          <p:cNvPr id="79" name="PlaceHolder 1"/>
           <p:cNvSpPr>
             <a:spLocks noGrp="1"/>
           </p:cNvSpPr>
@@ -7096,7 +8698,7 @@
       </p:sp>
       <p:sp>
         <p:nvSpPr>
-          <p:cNvPr id="77" name="PlaceHolder 2"/>
+          <p:cNvPr id="80" name="PlaceHolder 2"/>
           <p:cNvSpPr>
             <a:spLocks noGrp="1"/>
           </p:cNvSpPr>
@@ -7186,7 +8788,7 @@
       </p:grpSpPr>
       <p:sp>
         <p:nvSpPr>
-          <p:cNvPr id="78" name="PlaceHolder 1"/>
+          <p:cNvPr id="81" name="PlaceHolder 1"/>
           <p:cNvSpPr>
             <a:spLocks noGrp="1"/>
           </p:cNvSpPr>
@@ -7238,7 +8840,7 @@
       </p:sp>
       <p:sp>
         <p:nvSpPr>
-          <p:cNvPr id="79" name="PlaceHolder 2"/>
+          <p:cNvPr id="82" name="PlaceHolder 2"/>
           <p:cNvSpPr>
             <a:spLocks noGrp="1"/>
           </p:cNvSpPr>
@@ -7426,7 +9028,7 @@
       </p:grpSpPr>
       <p:sp>
         <p:nvSpPr>
-          <p:cNvPr id="80" name="Rectangle 1"/>
+          <p:cNvPr id="83" name="Rectangle 1"/>
           <p:cNvSpPr/>
           <p:nvPr/>
         </p:nvSpPr>
@@ -7491,7 +9093,7 @@
       </p:sp>
       <p:sp>
         <p:nvSpPr>
-          <p:cNvPr id="81" name="Oval 2"/>
+          <p:cNvPr id="84" name="Oval 2"/>
           <p:cNvSpPr/>
           <p:nvPr/>
         </p:nvSpPr>
@@ -7542,7 +9144,7 @@
       </p:sp>
       <p:sp>
         <p:nvSpPr>
-          <p:cNvPr id="82" name="TextBox 3"/>
+          <p:cNvPr id="85" name="TextBox 3"/>
           <p:cNvSpPr/>
           <p:nvPr/>
         </p:nvSpPr>
@@ -7595,7 +9197,7 @@
       </p:sp>
       <p:pic>
         <p:nvPicPr>
-          <p:cNvPr id="83" name="Picture 4" descr="pic.png"/>
+          <p:cNvPr id="86" name="Picture 4" descr="pic.png"/>
           <p:cNvPicPr/>
           <p:nvPr/>
         </p:nvPicPr>
@@ -7618,7 +9220,7 @@
       </p:pic>
       <p:grpSp>
         <p:nvGrpSpPr>
-          <p:cNvPr id="84" name="Group 5"/>
+          <p:cNvPr id="87" name="Group 5"/>
           <p:cNvGrpSpPr/>
           <p:nvPr/>
         </p:nvGrpSpPr>
@@ -7632,7 +9234,7 @@
         </p:grpSpPr>
         <p:sp>
           <p:nvSpPr>
-            <p:cNvPr id="85" name="Rectangle 6"/>
+            <p:cNvPr id="88" name="Rectangle 6"/>
             <p:cNvSpPr/>
             <p:nvPr/>
           </p:nvSpPr>
@@ -7683,7 +9285,7 @@
         </p:sp>
         <p:sp>
           <p:nvSpPr>
-            <p:cNvPr id="86" name="Rectangle 7"/>
+            <p:cNvPr id="89" name="Rectangle 7"/>
             <p:cNvSpPr/>
             <p:nvPr/>
           </p:nvSpPr>
@@ -7733,6 +9335,818 @@
           </p:txBody>
         </p:sp>
       </p:grpSp>
+    </p:spTree>
+  </p:cSld>
+  <mc:AlternateContent>
+    <mc:Choice Requires="p14">
+      <p:transition spd="slow" p14:dur="2000"/>
+    </mc:Choice>
+    <mc:Fallback>
+      <p:transition spd="slow"/>
+    </mc:Fallback>
+  </mc:AlternateContent>
+</p:sld>
+</file>
+
+<file path=ppt/slides/slide4.xml><?xml version="1.0" encoding="utf-8"?>
+<p:sld xmlns:a="http://schemas.openxmlformats.org/drawingml/2006/main" xmlns:p="http://schemas.openxmlformats.org/presentationml/2006/main" xmlns:r="http://schemas.openxmlformats.org/officeDocument/2006/relationships" xmlns:p14="http://schemas.microsoft.com/office/powerpoint/2010/main" xmlns:p15="http://schemas.microsoft.com/office/powerpoint/2012/main" xmlns:mc="http://schemas.openxmlformats.org/markup-compatibility/2006">
+  <p:cSld>
+    <p:spTree>
+      <p:nvGrpSpPr>
+        <p:cNvPr id="1" name=""/>
+        <p:cNvGrpSpPr/>
+        <p:nvPr/>
+      </p:nvGrpSpPr>
+      <p:grpSpPr>
+        <a:xfrm>
+          <a:off x="0" y="0"/>
+          <a:ext cx="0" cy="0"/>
+          <a:chOff x="0" y="0"/>
+          <a:chExt cx="0" cy="0"/>
+        </a:xfrm>
+      </p:grpSpPr>
+      <p:sp>
+        <p:nvSpPr>
+          <p:cNvPr id="90" name="PlaceHolder 1"/>
+          <p:cNvSpPr>
+            <a:spLocks noGrp="1"/>
+          </p:cNvSpPr>
+          <p:nvPr>
+            <p:ph type="title"/>
+          </p:nvPr>
+        </p:nvSpPr>
+        <p:spPr>
+          <a:xfrm>
+            <a:off x="457200" y="274680"/>
+            <a:ext cx="8229240" cy="1142640"/>
+          </a:xfrm>
+          <a:prstGeom prst="rect">
+            <a:avLst/>
+          </a:prstGeom>
+          <a:noFill/>
+          <a:ln w="0">
+            <a:noFill/>
+          </a:ln>
+        </p:spPr>
+        <p:txBody>
+          <a:bodyPr lIns="91440" rIns="91440" tIns="45720" bIns="45720" anchor="ctr">
+            <a:noAutofit/>
+          </a:bodyPr>
+          <a:p>
+            <a:pPr indent="0" algn="ctr" defTabSz="457200">
+              <a:lnSpc>
+                <a:spcPct val="100000"/>
+              </a:lnSpc>
+              <a:buNone/>
+            </a:pPr>
+            <a:r>
+              <a:rPr b="0" lang="en-US" sz="4400" spc="-1" strike="noStrike">
+                <a:solidFill>
+                  <a:schemeClr val="dk1"/>
+                </a:solidFill>
+                <a:latin typeface="Calibri"/>
+              </a:rPr>
+              <a:t>Tables and charts</a:t>
+            </a:r>
+            <a:endParaRPr b="0" lang="en-US" sz="4400" spc="-1" strike="noStrike">
+              <a:solidFill>
+                <a:schemeClr val="dk1"/>
+              </a:solidFill>
+              <a:latin typeface="Calibri"/>
+            </a:endParaRPr>
+          </a:p>
+        </p:txBody>
+      </p:sp>
+      <p:graphicFrame>
+        <p:nvGraphicFramePr>
+          <p:cNvPr id="91" name="Table 2"/>
+          <p:cNvGraphicFramePr/>
+          <p:nvPr/>
+        </p:nvGraphicFramePr>
+        <p:xfrm>
+          <a:off x="457200" y="1371600"/>
+          <a:ext cx="3656520" cy="1096920"/>
+        </p:xfrm>
+        <a:graphic>
+          <a:graphicData uri="http://schemas.openxmlformats.org/drawingml/2006/table">
+            <a:tbl>
+              <a:tblPr/>
+              <a:tblGrid>
+                <a:gridCol w="1218960"/>
+                <a:gridCol w="1218960"/>
+                <a:gridCol w="1218960"/>
+              </a:tblGrid>
+              <a:tr h="365760">
+                <a:tc>
+                  <a:txBody>
+                    <a:bodyPr anchor="t">
+                      <a:noAutofit/>
+                    </a:bodyPr>
+                    <a:p>
+                      <a:endParaRPr b="0" lang="en-US" sz="1800" spc="-1" strike="noStrike">
+                        <a:solidFill>
+                          <a:srgbClr val="ffffff"/>
+                        </a:solidFill>
+                        <a:latin typeface="Calibri"/>
+                      </a:endParaRPr>
+                    </a:p>
+                  </a:txBody>
+                  <a:tcPr anchor="t" marL="91440" marR="91440">
+                    <a:lnL w="12240">
+                      <a:solidFill>
+                        <a:srgbClr val="ffffff"/>
+                      </a:solidFill>
+                      <a:prstDash val="solid"/>
+                    </a:lnL>
+                    <a:lnR w="12240">
+                      <a:solidFill>
+                        <a:srgbClr val="ffffff"/>
+                      </a:solidFill>
+                      <a:prstDash val="solid"/>
+                    </a:lnR>
+                    <a:lnT w="12240">
+                      <a:solidFill>
+                        <a:srgbClr val="ffffff"/>
+                      </a:solidFill>
+                      <a:prstDash val="solid"/>
+                    </a:lnT>
+                    <a:lnB w="12240">
+                      <a:solidFill>
+                        <a:srgbClr val="ffffff"/>
+                      </a:solidFill>
+                      <a:prstDash val="solid"/>
+                    </a:lnB>
+                    <a:solidFill>
+                      <a:srgbClr val="4f81bd"/>
+                    </a:solidFill>
+                  </a:tcPr>
+                </a:tc>
+                <a:tc>
+                  <a:txBody>
+                    <a:bodyPr anchor="t">
+                      <a:noAutofit/>
+                    </a:bodyPr>
+                    <a:p>
+                      <a:pPr defTabSz="457200">
+                        <a:lnSpc>
+                          <a:spcPct val="100000"/>
+                        </a:lnSpc>
+                      </a:pPr>
+                      <a:r>
+                        <a:rPr b="0" lang="en-US" sz="1800" spc="-1" strike="noStrike">
+                          <a:solidFill>
+                            <a:srgbClr val="ffffff"/>
+                          </a:solidFill>
+                          <a:latin typeface="Calibri"/>
+                        </a:rPr>
+                        <a:t>Q1</a:t>
+                      </a:r>
+                      <a:endParaRPr b="0" lang="en-US" sz="1800" spc="-1" strike="noStrike">
+                        <a:solidFill>
+                          <a:srgbClr val="ffffff"/>
+                        </a:solidFill>
+                        <a:latin typeface="Arial"/>
+                      </a:endParaRPr>
+                    </a:p>
+                  </a:txBody>
+                  <a:tcPr anchor="t" marL="91440" marR="91440">
+                    <a:lnL w="12240">
+                      <a:solidFill>
+                        <a:srgbClr val="ffffff"/>
+                      </a:solidFill>
+                      <a:prstDash val="solid"/>
+                    </a:lnL>
+                    <a:lnR w="12240">
+                      <a:solidFill>
+                        <a:srgbClr val="ffffff"/>
+                      </a:solidFill>
+                      <a:prstDash val="solid"/>
+                    </a:lnR>
+                    <a:lnT w="12240">
+                      <a:solidFill>
+                        <a:srgbClr val="ffffff"/>
+                      </a:solidFill>
+                      <a:prstDash val="solid"/>
+                    </a:lnT>
+                    <a:lnB w="12240">
+                      <a:solidFill>
+                        <a:srgbClr val="ffffff"/>
+                      </a:solidFill>
+                      <a:prstDash val="solid"/>
+                    </a:lnB>
+                    <a:solidFill>
+                      <a:srgbClr val="4f81bd"/>
+                    </a:solidFill>
+                  </a:tcPr>
+                </a:tc>
+                <a:tc>
+                  <a:txBody>
+                    <a:bodyPr anchor="t">
+                      <a:noAutofit/>
+                    </a:bodyPr>
+                    <a:p>
+                      <a:pPr defTabSz="457200">
+                        <a:lnSpc>
+                          <a:spcPct val="100000"/>
+                        </a:lnSpc>
+                      </a:pPr>
+                      <a:r>
+                        <a:rPr b="0" lang="en-US" sz="1800" spc="-1" strike="noStrike">
+                          <a:solidFill>
+                            <a:srgbClr val="ffffff"/>
+                          </a:solidFill>
+                          <a:latin typeface="Calibri"/>
+                        </a:rPr>
+                        <a:t>Q2</a:t>
+                      </a:r>
+                      <a:endParaRPr b="0" lang="en-US" sz="1800" spc="-1" strike="noStrike">
+                        <a:solidFill>
+                          <a:srgbClr val="ffffff"/>
+                        </a:solidFill>
+                        <a:latin typeface="Arial"/>
+                      </a:endParaRPr>
+                    </a:p>
+                  </a:txBody>
+                  <a:tcPr anchor="t" marL="91440" marR="91440">
+                    <a:lnL w="12240">
+                      <a:solidFill>
+                        <a:srgbClr val="ffffff"/>
+                      </a:solidFill>
+                      <a:prstDash val="solid"/>
+                    </a:lnL>
+                    <a:lnR w="12240">
+                      <a:solidFill>
+                        <a:srgbClr val="ffffff"/>
+                      </a:solidFill>
+                      <a:prstDash val="solid"/>
+                    </a:lnR>
+                    <a:lnT w="12240">
+                      <a:solidFill>
+                        <a:srgbClr val="ffffff"/>
+                      </a:solidFill>
+                      <a:prstDash val="solid"/>
+                    </a:lnT>
+                    <a:lnB w="12240">
+                      <a:solidFill>
+                        <a:srgbClr val="ffffff"/>
+                      </a:solidFill>
+                      <a:prstDash val="solid"/>
+                    </a:lnB>
+                    <a:solidFill>
+                      <a:srgbClr val="4f81bd"/>
+                    </a:solidFill>
+                  </a:tcPr>
+                </a:tc>
+              </a:tr>
+              <a:tr h="365760">
+                <a:tc>
+                  <a:txBody>
+                    <a:bodyPr anchor="t">
+                      <a:noAutofit/>
+                    </a:bodyPr>
+                    <a:p>
+                      <a:pPr defTabSz="457200">
+                        <a:lnSpc>
+                          <a:spcPct val="100000"/>
+                        </a:lnSpc>
+                      </a:pPr>
+                      <a:r>
+                        <a:rPr b="0" lang="en-US" sz="1800" spc="-1" strike="noStrike">
+                          <a:solidFill>
+                            <a:srgbClr val="000000"/>
+                          </a:solidFill>
+                          <a:latin typeface="Calibri"/>
+                        </a:rPr>
+                        <a:t>North</a:t>
+                      </a:r>
+                      <a:endParaRPr b="0" lang="en-US" sz="1800" spc="-1" strike="noStrike">
+                        <a:solidFill>
+                          <a:srgbClr val="000000"/>
+                        </a:solidFill>
+                        <a:latin typeface="Arial"/>
+                      </a:endParaRPr>
+                    </a:p>
+                  </a:txBody>
+                  <a:tcPr anchor="t" marL="91440" marR="91440">
+                    <a:lnL w="12240">
+                      <a:solidFill>
+                        <a:srgbClr val="ffffff"/>
+                      </a:solidFill>
+                      <a:prstDash val="solid"/>
+                    </a:lnL>
+                    <a:lnR w="12240">
+                      <a:solidFill>
+                        <a:srgbClr val="ffffff"/>
+                      </a:solidFill>
+                      <a:prstDash val="solid"/>
+                    </a:lnR>
+                    <a:lnT w="12240">
+                      <a:solidFill>
+                        <a:srgbClr val="ffffff"/>
+                      </a:solidFill>
+                      <a:prstDash val="solid"/>
+                    </a:lnT>
+                    <a:lnB w="12240">
+                      <a:solidFill>
+                        <a:srgbClr val="ffffff"/>
+                      </a:solidFill>
+                      <a:prstDash val="solid"/>
+                    </a:lnB>
+                    <a:solidFill>
+                      <a:srgbClr val="d0d8e7"/>
+                    </a:solidFill>
+                  </a:tcPr>
+                </a:tc>
+                <a:tc>
+                  <a:txBody>
+                    <a:bodyPr anchor="t">
+                      <a:noAutofit/>
+                    </a:bodyPr>
+                    <a:p>
+                      <a:pPr defTabSz="457200">
+                        <a:lnSpc>
+                          <a:spcPct val="100000"/>
+                        </a:lnSpc>
+                      </a:pPr>
+                      <a:r>
+                        <a:rPr b="0" lang="en-US" sz="1800" spc="-1" strike="noStrike">
+                          <a:solidFill>
+                            <a:srgbClr val="000000"/>
+                          </a:solidFill>
+                          <a:latin typeface="Calibri"/>
+                        </a:rPr>
+                        <a:t>5</a:t>
+                      </a:r>
+                      <a:endParaRPr b="0" lang="en-US" sz="1800" spc="-1" strike="noStrike">
+                        <a:solidFill>
+                          <a:srgbClr val="000000"/>
+                        </a:solidFill>
+                        <a:latin typeface="Arial"/>
+                      </a:endParaRPr>
+                    </a:p>
+                  </a:txBody>
+                  <a:tcPr anchor="t" marL="91440" marR="91440">
+                    <a:lnL w="12240">
+                      <a:solidFill>
+                        <a:srgbClr val="ffffff"/>
+                      </a:solidFill>
+                      <a:prstDash val="solid"/>
+                    </a:lnL>
+                    <a:lnR w="12240">
+                      <a:solidFill>
+                        <a:srgbClr val="ffffff"/>
+                      </a:solidFill>
+                      <a:prstDash val="solid"/>
+                    </a:lnR>
+                    <a:lnT w="12240">
+                      <a:solidFill>
+                        <a:srgbClr val="ffffff"/>
+                      </a:solidFill>
+                      <a:prstDash val="solid"/>
+                    </a:lnT>
+                    <a:lnB w="12240">
+                      <a:solidFill>
+                        <a:srgbClr val="ffffff"/>
+                      </a:solidFill>
+                      <a:prstDash val="solid"/>
+                    </a:lnB>
+                    <a:solidFill>
+                      <a:srgbClr val="d0d8e7"/>
+                    </a:solidFill>
+                  </a:tcPr>
+                </a:tc>
+                <a:tc>
+                  <a:txBody>
+                    <a:bodyPr anchor="t">
+                      <a:noAutofit/>
+                    </a:bodyPr>
+                    <a:p>
+                      <a:pPr defTabSz="457200">
+                        <a:lnSpc>
+                          <a:spcPct val="100000"/>
+                        </a:lnSpc>
+                      </a:pPr>
+                      <a:r>
+                        <a:rPr b="0" lang="en-US" sz="1800" spc="-1" strike="noStrike">
+                          <a:solidFill>
+                            <a:srgbClr val="000000"/>
+                          </a:solidFill>
+                          <a:latin typeface="Calibri"/>
+                        </a:rPr>
+                        <a:t>6</a:t>
+                      </a:r>
+                      <a:endParaRPr b="0" lang="en-US" sz="1800" spc="-1" strike="noStrike">
+                        <a:solidFill>
+                          <a:srgbClr val="000000"/>
+                        </a:solidFill>
+                        <a:latin typeface="Arial"/>
+                      </a:endParaRPr>
+                    </a:p>
+                  </a:txBody>
+                  <a:tcPr anchor="t" marL="91440" marR="91440">
+                    <a:lnL w="12240">
+                      <a:solidFill>
+                        <a:srgbClr val="ffffff"/>
+                      </a:solidFill>
+                      <a:prstDash val="solid"/>
+                    </a:lnL>
+                    <a:lnR w="12240">
+                      <a:solidFill>
+                        <a:srgbClr val="ffffff"/>
+                      </a:solidFill>
+                      <a:prstDash val="solid"/>
+                    </a:lnR>
+                    <a:lnT w="12240">
+                      <a:solidFill>
+                        <a:srgbClr val="ffffff"/>
+                      </a:solidFill>
+                      <a:prstDash val="solid"/>
+                    </a:lnT>
+                    <a:lnB w="12240">
+                      <a:solidFill>
+                        <a:srgbClr val="ffffff"/>
+                      </a:solidFill>
+                      <a:prstDash val="solid"/>
+                    </a:lnB>
+                    <a:solidFill>
+                      <a:srgbClr val="d0d8e7"/>
+                    </a:solidFill>
+                  </a:tcPr>
+                </a:tc>
+              </a:tr>
+              <a:tr h="365760">
+                <a:tc>
+                  <a:txBody>
+                    <a:bodyPr anchor="t">
+                      <a:noAutofit/>
+                    </a:bodyPr>
+                    <a:p>
+                      <a:pPr defTabSz="457200">
+                        <a:lnSpc>
+                          <a:spcPct val="100000"/>
+                        </a:lnSpc>
+                      </a:pPr>
+                      <a:r>
+                        <a:rPr b="0" lang="en-US" sz="1800" spc="-1" strike="noStrike">
+                          <a:solidFill>
+                            <a:srgbClr val="000000"/>
+                          </a:solidFill>
+                          <a:latin typeface="Calibri"/>
+                        </a:rPr>
+                        <a:t>South</a:t>
+                      </a:r>
+                      <a:endParaRPr b="0" lang="en-US" sz="1800" spc="-1" strike="noStrike">
+                        <a:solidFill>
+                          <a:srgbClr val="000000"/>
+                        </a:solidFill>
+                        <a:latin typeface="Arial"/>
+                      </a:endParaRPr>
+                    </a:p>
+                  </a:txBody>
+                  <a:tcPr anchor="t" marL="91440" marR="91440">
+                    <a:lnL w="12240">
+                      <a:solidFill>
+                        <a:srgbClr val="ffffff"/>
+                      </a:solidFill>
+                      <a:prstDash val="solid"/>
+                    </a:lnL>
+                    <a:lnR w="12240">
+                      <a:solidFill>
+                        <a:srgbClr val="ffffff"/>
+                      </a:solidFill>
+                      <a:prstDash val="solid"/>
+                    </a:lnR>
+                    <a:lnT w="12240">
+                      <a:solidFill>
+                        <a:srgbClr val="ffffff"/>
+                      </a:solidFill>
+                      <a:prstDash val="solid"/>
+                    </a:lnT>
+                    <a:lnB w="12240">
+                      <a:solidFill>
+                        <a:srgbClr val="ffffff"/>
+                      </a:solidFill>
+                      <a:prstDash val="solid"/>
+                    </a:lnB>
+                    <a:solidFill>
+                      <a:srgbClr val="e9ecf3"/>
+                    </a:solidFill>
+                  </a:tcPr>
+                </a:tc>
+                <a:tc>
+                  <a:txBody>
+                    <a:bodyPr anchor="t">
+                      <a:noAutofit/>
+                    </a:bodyPr>
+                    <a:p>
+                      <a:pPr defTabSz="457200">
+                        <a:lnSpc>
+                          <a:spcPct val="100000"/>
+                        </a:lnSpc>
+                      </a:pPr>
+                      <a:r>
+                        <a:rPr b="0" lang="en-US" sz="1800" spc="-1" strike="noStrike">
+                          <a:solidFill>
+                            <a:srgbClr val="000000"/>
+                          </a:solidFill>
+                          <a:latin typeface="Calibri"/>
+                        </a:rPr>
+                        <a:t>8</a:t>
+                      </a:r>
+                      <a:endParaRPr b="0" lang="en-US" sz="1800" spc="-1" strike="noStrike">
+                        <a:solidFill>
+                          <a:srgbClr val="000000"/>
+                        </a:solidFill>
+                        <a:latin typeface="Arial"/>
+                      </a:endParaRPr>
+                    </a:p>
+                  </a:txBody>
+                  <a:tcPr anchor="t" marL="91440" marR="91440">
+                    <a:lnL w="12240">
+                      <a:solidFill>
+                        <a:srgbClr val="ffffff"/>
+                      </a:solidFill>
+                      <a:prstDash val="solid"/>
+                    </a:lnL>
+                    <a:lnR w="12240">
+                      <a:solidFill>
+                        <a:srgbClr val="ffffff"/>
+                      </a:solidFill>
+                      <a:prstDash val="solid"/>
+                    </a:lnR>
+                    <a:lnT w="12240">
+                      <a:solidFill>
+                        <a:srgbClr val="ffffff"/>
+                      </a:solidFill>
+                      <a:prstDash val="solid"/>
+                    </a:lnT>
+                    <a:lnB w="12240">
+                      <a:solidFill>
+                        <a:srgbClr val="ffffff"/>
+                      </a:solidFill>
+                      <a:prstDash val="solid"/>
+                    </a:lnB>
+                    <a:solidFill>
+                      <a:srgbClr val="e9ecf3"/>
+                    </a:solidFill>
+                  </a:tcPr>
+                </a:tc>
+                <a:tc>
+                  <a:txBody>
+                    <a:bodyPr anchor="t">
+                      <a:noAutofit/>
+                    </a:bodyPr>
+                    <a:p>
+                      <a:pPr defTabSz="457200">
+                        <a:lnSpc>
+                          <a:spcPct val="100000"/>
+                        </a:lnSpc>
+                      </a:pPr>
+                      <a:r>
+                        <a:rPr b="0" lang="en-US" sz="1800" spc="-1" strike="noStrike">
+                          <a:solidFill>
+                            <a:srgbClr val="000000"/>
+                          </a:solidFill>
+                          <a:latin typeface="Calibri"/>
+                        </a:rPr>
+                        <a:t>7</a:t>
+                      </a:r>
+                      <a:endParaRPr b="0" lang="en-US" sz="1800" spc="-1" strike="noStrike">
+                        <a:solidFill>
+                          <a:srgbClr val="000000"/>
+                        </a:solidFill>
+                        <a:latin typeface="Arial"/>
+                      </a:endParaRPr>
+                    </a:p>
+                  </a:txBody>
+                  <a:tcPr anchor="t" marL="91440" marR="91440">
+                    <a:lnL w="12240">
+                      <a:solidFill>
+                        <a:srgbClr val="ffffff"/>
+                      </a:solidFill>
+                      <a:prstDash val="solid"/>
+                    </a:lnL>
+                    <a:lnR w="12240">
+                      <a:solidFill>
+                        <a:srgbClr val="ffffff"/>
+                      </a:solidFill>
+                      <a:prstDash val="solid"/>
+                    </a:lnR>
+                    <a:lnT w="12240">
+                      <a:solidFill>
+                        <a:srgbClr val="ffffff"/>
+                      </a:solidFill>
+                      <a:prstDash val="solid"/>
+                    </a:lnT>
+                    <a:lnB w="12240">
+                      <a:solidFill>
+                        <a:srgbClr val="ffffff"/>
+                      </a:solidFill>
+                      <a:prstDash val="solid"/>
+                    </a:lnB>
+                    <a:solidFill>
+                      <a:srgbClr val="e9ecf3"/>
+                    </a:solidFill>
+                  </a:tcPr>
+                </a:tc>
+              </a:tr>
+            </a:tbl>
+          </a:graphicData>
+        </a:graphic>
+      </p:graphicFrame>
+      <p:graphicFrame>
+        <p:nvGraphicFramePr>
+          <p:cNvPr id="92" name="Chart 3"/>
+          <p:cNvGraphicFramePr/>
+          <p:nvPr/>
+        </p:nvGraphicFramePr>
+        <p:xfrm>
+          <a:off x="4572000" y="1371600"/>
+          <a:ext cx="4114440" cy="2285640"/>
+        </p:xfrm>
+        <a:graphic>
+          <a:graphicData uri="http://schemas.openxmlformats.org/drawingml/2006/chart">
+            <c:chart xmlns:c="http://schemas.openxmlformats.org/drawingml/2006/chart" xmlns:r="http://schemas.openxmlformats.org/officeDocument/2006/relationships" r:id="rId1"/>
+          </a:graphicData>
+        </a:graphic>
+      </p:graphicFrame>
+      <p:graphicFrame>
+        <p:nvGraphicFramePr>
+          <p:cNvPr id="93" name="Chart 4"/>
+          <p:cNvGraphicFramePr/>
+          <p:nvPr/>
+        </p:nvGraphicFramePr>
+        <p:xfrm>
+          <a:off x="457200" y="2743200"/>
+          <a:ext cx="2742840" cy="2285640"/>
+        </p:xfrm>
+        <a:graphic>
+          <a:graphicData uri="http://schemas.openxmlformats.org/drawingml/2006/chart">
+            <c:chart xmlns:c="http://schemas.openxmlformats.org/drawingml/2006/chart" xmlns:r="http://schemas.openxmlformats.org/officeDocument/2006/relationships" r:id="rId2"/>
+          </a:graphicData>
+        </a:graphic>
+      </p:graphicFrame>
+      <p:graphicFrame>
+        <p:nvGraphicFramePr>
+          <p:cNvPr id="94" name="Chart 5"/>
+          <p:cNvGraphicFramePr/>
+          <p:nvPr/>
+        </p:nvGraphicFramePr>
+        <p:xfrm>
+          <a:off x="3200400" y="3840480"/>
+          <a:ext cx="2742840" cy="2285640"/>
+        </p:xfrm>
+        <a:graphic>
+          <a:graphicData uri="http://schemas.openxmlformats.org/drawingml/2006/chart">
+            <c:chart xmlns:c="http://schemas.openxmlformats.org/drawingml/2006/chart" xmlns:r="http://schemas.openxmlformats.org/officeDocument/2006/relationships" r:id="rId3"/>
+          </a:graphicData>
+        </a:graphic>
+      </p:graphicFrame>
+      <p:cxnSp>
+        <p:nvCxnSpPr>
+          <p:cNvPr id="95" name="Connector 6"/>
+          <p:cNvCxnSpPr/>
+          <p:nvPr/>
+        </p:nvCxnSpPr>
+        <p:spPr>
+          <a:xfrm>
+            <a:off x="5943600" y="4572000"/>
+            <a:ext cx="2286360" cy="914760"/>
+          </a:xfrm>
+          <a:prstGeom prst="straightConnector1">
+            <a:avLst/>
+          </a:prstGeom>
+          <a:ln w="25560">
+            <a:solidFill>
+              <a:schemeClr val="accent1"/>
+            </a:solidFill>
+            <a:round/>
+            <a:tailEnd len="med" type="triangle" w="med"/>
+          </a:ln>
+        </p:spPr>
+      </p:cxnSp>
+      <p:sp>
+        <p:nvSpPr>
+          <p:cNvPr id="96" name="5-Point Star 7"/>
+          <p:cNvSpPr/>
+          <p:nvPr/>
+        </p:nvSpPr>
+        <p:spPr>
+          <a:xfrm rot="2700000">
+            <a:off x="7315200" y="3657240"/>
+            <a:ext cx="1371240" cy="1371240"/>
+          </a:xfrm>
+          <a:prstGeom prst="star5">
+            <a:avLst>
+              <a:gd name="adj" fmla="val 19098"/>
+              <a:gd name="hf" fmla="val 105146"/>
+              <a:gd name="vf" fmla="val 110557"/>
+            </a:avLst>
+          </a:prstGeom>
+          <a:gradFill rotWithShape="0">
+            <a:gsLst>
+              <a:gs pos="0">
+                <a:srgbClr val="3e7fcc"/>
+              </a:gs>
+              <a:gs pos="100000">
+                <a:srgbClr val="a4c1ff"/>
+              </a:gs>
+            </a:gsLst>
+            <a:lin ang="18900000"/>
+          </a:gradFill>
+          <a:ln w="9360">
+            <a:solidFill>
+              <a:srgbClr val="4a7ebb"/>
+            </a:solidFill>
+            <a:round/>
+          </a:ln>
+          <a:effectLst>
+            <a:outerShdw dist="23040" dir="5400000" blurRad="39960" rotWithShape="0">
+              <a:srgbClr val="000000">
+                <a:alpha val="35000"/>
+              </a:srgbClr>
+            </a:outerShdw>
+          </a:effectLst>
+        </p:spPr>
+        <p:style>
+          <a:lnRef idx="0"/>
+          <a:fillRef idx="0"/>
+          <a:effectRef idx="0"/>
+          <a:fontRef idx="minor"/>
+        </p:style>
+        <p:txBody>
+          <a:bodyPr lIns="90000" rIns="90000" tIns="45000" bIns="45000" anchor="ctr">
+            <a:noAutofit/>
+          </a:bodyPr>
+          <a:p>
+            <a:endParaRPr b="0" lang="en-US" sz="1800" spc="-1" strike="noStrike">
+              <a:solidFill>
+                <a:schemeClr val="lt1"/>
+              </a:solidFill>
+              <a:latin typeface="Calibri"/>
+            </a:endParaRPr>
+          </a:p>
+        </p:txBody>
+      </p:sp>
+      <p:sp>
+        <p:nvSpPr>
+          <p:cNvPr id="97" name="Rectangle 8"/>
+          <p:cNvSpPr/>
+          <p:nvPr/>
+        </p:nvSpPr>
+        <p:spPr>
+          <a:xfrm>
+            <a:off x="6217920" y="5669280"/>
+            <a:ext cx="2285640" cy="914040"/>
+          </a:xfrm>
+          <a:prstGeom prst="rect">
+            <a:avLst/>
+          </a:prstGeom>
+          <a:gradFill rotWithShape="0">
+            <a:gsLst>
+              <a:gs pos="0">
+                <a:srgbClr val="ff0000"/>
+              </a:gs>
+              <a:gs pos="100000">
+                <a:srgbClr val="0000ff"/>
+              </a:gs>
+            </a:gsLst>
+            <a:lin ang="16200000"/>
+          </a:gradFill>
+          <a:ln w="9360">
+            <a:solidFill>
+              <a:srgbClr val="4a7ebb"/>
+            </a:solidFill>
+            <a:round/>
+          </a:ln>
+          <a:effectLst>
+            <a:outerShdw dist="23040" dir="5400000" blurRad="39960" rotWithShape="0">
+              <a:srgbClr val="000000">
+                <a:alpha val="35000"/>
+              </a:srgbClr>
+            </a:outerShdw>
+          </a:effectLst>
+        </p:spPr>
+        <p:style>
+          <a:lnRef idx="0"/>
+          <a:fillRef idx="0"/>
+          <a:effectRef idx="0"/>
+          <a:fontRef idx="minor"/>
+        </p:style>
+        <p:txBody>
+          <a:bodyPr lIns="90000" rIns="90000" tIns="45000" bIns="45000" anchor="ctr">
+            <a:noAutofit/>
+          </a:bodyPr>
+          <a:p>
+            <a:endParaRPr b="0" lang="en-US" sz="1800" spc="-1" strike="noStrike">
+              <a:solidFill>
+                <a:schemeClr val="lt1"/>
+              </a:solidFill>
+              <a:latin typeface="Calibri"/>
+            </a:endParaRPr>
+          </a:p>
+        </p:txBody>
+      </p:sp>
     </p:spTree>
   </p:cSld>
   <mc:AlternateContent>

</xml_diff>